<commit_message>
ONB 02: neutral Spanish, BB at work logo on every slide
Co-Authored-By: Claude Opus 5.5 <noreply@anthropic.com>
Claude-Session: https://claude.ai/code/session_01PSmnUj1LvutfXzpzQBGsxa
</commit_message>
<xml_diff>
--- a/onboarding/ONB02_Como_vamos_a_trabajar_juntas.pptx
+++ b/onboarding/ONB02_Como_vamos_a_trabajar_juntas.pptx
@@ -2333,16 +2333,40 @@
           <a:chExt cx="0" cy="0"/>
         </a:xfrm>
       </p:grpSpPr>
-      <p:sp>
-        <p:nvSpPr>
-          <p:cNvPr id="3" name="Text 0"/>
+      <p:pic>
+        <p:nvPicPr>
+          <p:cNvPr id="3" name="Image 0" descr="Breaking Barriers at work">    </p:cNvPr>
+          <p:cNvPicPr>
+            <a:picLocks noChangeAspect="1"/>
+          </p:cNvPicPr>
+          <p:nvPr/>
+        </p:nvPicPr>
+        <p:blipFill>
+          <a:blip r:embed="rId1"/>
+          <a:stretch>
+            <a:fillRect/>
+          </a:stretch>
+        </p:blipFill>
+        <p:spPr>
+          <a:xfrm>
+            <a:off x="640080" y="274320"/>
+            <a:ext cx="1188720" cy="542536"/>
+          </a:xfrm>
+          <a:prstGeom prst="rect">
+            <a:avLst/>
+          </a:prstGeom>
+        </p:spPr>
+      </p:pic>
+      <p:sp>
+        <p:nvSpPr>
+          <p:cNvPr id="4" name="Text 0"/>
           <p:cNvSpPr txBox="1"/>
           <p:nvPr/>
         </p:nvSpPr>
         <p:spPr>
           <a:xfrm>
-            <a:off x="640080" y="384048"/>
-            <a:ext cx="4572000" cy="274320"/>
+            <a:off x="7891272" y="384048"/>
+            <a:ext cx="3657600" cy="274320"/>
           </a:xfrm>
           <a:prstGeom prst="rect">
             <a:avLst/>
@@ -2354,86 +2378,47 @@
           <a:bodyPr wrap="square" lIns="0" tIns="0" rIns="0" bIns="0" rtlCol="0" anchor="ctr"/>
           <a:lstStyle/>
           <a:p>
-            <a:pPr indent="0" marL="0">
-              <a:buNone/>
-            </a:pPr>
-            <a:r>
-              <a:rPr lang="en-US" sz="1050" b="1" spc="300" kern="0" dirty="0">
-                <a:solidFill>
-                  <a:srgbClr val="C68C6C"/>
+            <a:pPr algn="r" indent="0" marL="0">
+              <a:buNone/>
+            </a:pPr>
+            <a:r>
+              <a:rPr lang="en-US" sz="1100" i="1" dirty="0">
+                <a:solidFill>
+                  <a:srgbClr val="8A6A55"/>
+                </a:solidFill>
+                <a:latin typeface="Source Serif Pro" pitchFamily="34" charset="0"/>
+                <a:ea typeface="Source Serif Pro" pitchFamily="34" charset="-122"/>
+                <a:cs typeface="Source Serif Pro" pitchFamily="34" charset="-120"/>
+              </a:rPr>
+              <a:t>by Flor Pérsico</a:t>
+            </a:r>
+            <a:pPr algn="r" indent="0" marL="0">
+              <a:buNone/>
+            </a:pPr>
+            <a:r>
+              <a:rPr lang="en-US" sz="1100" dirty="0">
+                <a:solidFill>
+                  <a:srgbClr val="8A6A55"/>
                 </a:solidFill>
                 <a:latin typeface="Open Sans" pitchFamily="34" charset="0"/>
                 <a:ea typeface="Open Sans" pitchFamily="34" charset="-122"/>
                 <a:cs typeface="Open Sans" pitchFamily="34" charset="-120"/>
               </a:rPr>
-              <a:t>BREAKING BARRIERS · AT WORK</a:t>
-            </a:r>
-            <a:endParaRPr lang="en-US" sz="1050" dirty="0"/>
-          </a:p>
-        </p:txBody>
-      </p:sp>
-      <p:sp>
-        <p:nvSpPr>
-          <p:cNvPr id="4" name="Text 1"/>
+              <a:t>   ·   02 / 09</a:t>
+            </a:r>
+            <a:endParaRPr lang="en-US" sz="1100" dirty="0"/>
+          </a:p>
+        </p:txBody>
+      </p:sp>
+      <p:sp>
+        <p:nvSpPr>
+          <p:cNvPr id="5" name="Text 1"/>
           <p:cNvSpPr txBox="1"/>
           <p:nvPr/>
         </p:nvSpPr>
         <p:spPr>
           <a:xfrm>
-            <a:off x="7891272" y="384048"/>
-            <a:ext cx="3657600" cy="274320"/>
-          </a:xfrm>
-          <a:prstGeom prst="rect">
-            <a:avLst/>
-          </a:prstGeom>
-          <a:noFill/>
-          <a:ln/>
-        </p:spPr>
-        <p:txBody>
-          <a:bodyPr wrap="square" lIns="0" tIns="0" rIns="0" bIns="0" rtlCol="0" anchor="ctr"/>
-          <a:lstStyle/>
-          <a:p>
-            <a:pPr algn="r" indent="0" marL="0">
-              <a:buNone/>
-            </a:pPr>
-            <a:r>
-              <a:rPr lang="en-US" sz="1100" i="1" dirty="0">
-                <a:solidFill>
-                  <a:srgbClr val="8A6A55"/>
-                </a:solidFill>
-                <a:latin typeface="Source Serif Pro" pitchFamily="34" charset="0"/>
-                <a:ea typeface="Source Serif Pro" pitchFamily="34" charset="-122"/>
-                <a:cs typeface="Source Serif Pro" pitchFamily="34" charset="-120"/>
-              </a:rPr>
-              <a:t>by Flor Pérsico</a:t>
-            </a:r>
-            <a:pPr algn="r" indent="0" marL="0">
-              <a:buNone/>
-            </a:pPr>
-            <a:r>
-              <a:rPr lang="en-US" sz="1100" dirty="0">
-                <a:solidFill>
-                  <a:srgbClr val="8A6A55"/>
-                </a:solidFill>
-                <a:latin typeface="Open Sans" pitchFamily="34" charset="0"/>
-                <a:ea typeface="Open Sans" pitchFamily="34" charset="-122"/>
-                <a:cs typeface="Open Sans" pitchFamily="34" charset="-120"/>
-              </a:rPr>
-              <a:t>   ·   02 / 09</a:t>
-            </a:r>
-            <a:endParaRPr lang="en-US" sz="1100" dirty="0"/>
-          </a:p>
-        </p:txBody>
-      </p:sp>
-      <p:sp>
-        <p:nvSpPr>
-          <p:cNvPr id="5" name="Text 2"/>
-          <p:cNvSpPr txBox="1"/>
-          <p:nvPr/>
-        </p:nvSpPr>
-        <p:spPr>
-          <a:xfrm>
-            <a:off x="640080" y="1097280"/>
+            <a:off x="640080" y="1280160"/>
             <a:ext cx="3429000" cy="1783080"/>
           </a:xfrm>
           <a:prstGeom prst="rect">
@@ -2469,13 +2454,13 @@
       </p:sp>
       <p:sp>
         <p:nvSpPr>
-          <p:cNvPr id="6" name="Text 3"/>
+          <p:cNvPr id="6" name="Text 2"/>
           <p:cNvSpPr txBox="1"/>
           <p:nvPr/>
         </p:nvSpPr>
         <p:spPr>
           <a:xfrm>
-            <a:off x="640080" y="2414016"/>
+            <a:off x="640080" y="2596896"/>
             <a:ext cx="3291840" cy="731520"/>
           </a:xfrm>
           <a:prstGeom prst="rect">
@@ -2508,13 +2493,13 @@
       </p:sp>
       <p:sp>
         <p:nvSpPr>
-          <p:cNvPr id="7" name="Shape 4"/>
+          <p:cNvPr id="7" name="Shape 3"/>
           <p:cNvSpPr/>
           <p:nvPr/>
         </p:nvSpPr>
         <p:spPr>
           <a:xfrm>
-            <a:off x="4389120" y="1143000"/>
+            <a:off x="4389120" y="1280160"/>
             <a:ext cx="7159752" cy="1051560"/>
           </a:xfrm>
           <a:prstGeom prst="roundRect">
@@ -2542,13 +2527,13 @@
       </p:sp>
       <p:sp>
         <p:nvSpPr>
-          <p:cNvPr id="8" name="Shape 5"/>
+          <p:cNvPr id="8" name="Shape 4"/>
           <p:cNvSpPr/>
           <p:nvPr/>
         </p:nvSpPr>
         <p:spPr>
           <a:xfrm>
-            <a:off x="4663440" y="1394460"/>
+            <a:off x="4663440" y="1531620"/>
             <a:ext cx="548640" cy="548640"/>
           </a:xfrm>
           <a:prstGeom prst="ellipse">
@@ -2567,13 +2552,13 @@
       </p:sp>
       <p:sp>
         <p:nvSpPr>
-          <p:cNvPr id="9" name="Text 6"/>
+          <p:cNvPr id="9" name="Text 5"/>
           <p:cNvSpPr txBox="1"/>
           <p:nvPr/>
         </p:nvSpPr>
         <p:spPr>
           <a:xfrm>
-            <a:off x="4663440" y="1394460"/>
+            <a:off x="4663440" y="1531620"/>
             <a:ext cx="548640" cy="548640"/>
           </a:xfrm>
           <a:prstGeom prst="rect">
@@ -2606,13 +2591,13 @@
       </p:sp>
       <p:sp>
         <p:nvSpPr>
-          <p:cNvPr id="10" name="Text 7"/>
+          <p:cNvPr id="10" name="Text 6"/>
           <p:cNvSpPr txBox="1"/>
           <p:nvPr/>
         </p:nvSpPr>
         <p:spPr>
           <a:xfrm>
-            <a:off x="5440680" y="1143000"/>
+            <a:off x="5440680" y="1280160"/>
             <a:ext cx="5239512" cy="1051560"/>
           </a:xfrm>
           <a:prstGeom prst="rect">
@@ -2659,21 +2644,21 @@
       </p:sp>
       <p:pic>
         <p:nvPicPr>
-          <p:cNvPr id="11" name="Image 0" descr="preencoded.png">    </p:cNvPr>
+          <p:cNvPr id="11" name="Image 1" descr="preencoded.png">    </p:cNvPr>
           <p:cNvPicPr>
             <a:picLocks noChangeAspect="1"/>
           </p:cNvPicPr>
           <p:nvPr/>
         </p:nvPicPr>
         <p:blipFill>
-          <a:blip r:embed="rId1"/>
+          <a:blip r:embed="rId2"/>
           <a:stretch>
             <a:fillRect/>
           </a:stretch>
         </p:blipFill>
         <p:spPr>
           <a:xfrm>
-            <a:off x="10817352" y="1463040"/>
+            <a:off x="10817352" y="1600200"/>
             <a:ext cx="411480" cy="411480"/>
           </a:xfrm>
           <a:prstGeom prst="rect">
@@ -2683,13 +2668,13 @@
       </p:pic>
       <p:sp>
         <p:nvSpPr>
-          <p:cNvPr id="12" name="Shape 8"/>
+          <p:cNvPr id="12" name="Shape 7"/>
           <p:cNvSpPr/>
           <p:nvPr/>
         </p:nvSpPr>
         <p:spPr>
           <a:xfrm>
-            <a:off x="4389120" y="2395728"/>
+            <a:off x="4389120" y="2532888"/>
             <a:ext cx="7159752" cy="1051560"/>
           </a:xfrm>
           <a:prstGeom prst="roundRect">
@@ -2717,13 +2702,13 @@
       </p:sp>
       <p:sp>
         <p:nvSpPr>
-          <p:cNvPr id="13" name="Shape 9"/>
+          <p:cNvPr id="13" name="Shape 8"/>
           <p:cNvSpPr/>
           <p:nvPr/>
         </p:nvSpPr>
         <p:spPr>
           <a:xfrm>
-            <a:off x="4663440" y="2647188"/>
+            <a:off x="4663440" y="2784348"/>
             <a:ext cx="548640" cy="548640"/>
           </a:xfrm>
           <a:prstGeom prst="ellipse">
@@ -2742,13 +2727,13 @@
       </p:sp>
       <p:sp>
         <p:nvSpPr>
-          <p:cNvPr id="14" name="Text 10"/>
+          <p:cNvPr id="14" name="Text 9"/>
           <p:cNvSpPr txBox="1"/>
           <p:nvPr/>
         </p:nvSpPr>
         <p:spPr>
           <a:xfrm>
-            <a:off x="4663440" y="2647188"/>
+            <a:off x="4663440" y="2784348"/>
             <a:ext cx="548640" cy="548640"/>
           </a:xfrm>
           <a:prstGeom prst="rect">
@@ -2781,13 +2766,13 @@
       </p:sp>
       <p:sp>
         <p:nvSpPr>
-          <p:cNvPr id="15" name="Text 11"/>
+          <p:cNvPr id="15" name="Text 10"/>
           <p:cNvSpPr txBox="1"/>
           <p:nvPr/>
         </p:nvSpPr>
         <p:spPr>
           <a:xfrm>
-            <a:off x="5440680" y="2395728"/>
+            <a:off x="5440680" y="2532888"/>
             <a:ext cx="5239512" cy="1051560"/>
           </a:xfrm>
           <a:prstGeom prst="rect">
@@ -2820,21 +2805,21 @@
       </p:sp>
       <p:pic>
         <p:nvPicPr>
-          <p:cNvPr id="16" name="Image 1" descr="preencoded.png">    </p:cNvPr>
+          <p:cNvPr id="16" name="Image 2" descr="preencoded.png">    </p:cNvPr>
           <p:cNvPicPr>
             <a:picLocks noChangeAspect="1"/>
           </p:cNvPicPr>
           <p:nvPr/>
         </p:nvPicPr>
         <p:blipFill>
-          <a:blip r:embed="rId2"/>
+          <a:blip r:embed="rId3"/>
           <a:stretch>
             <a:fillRect/>
           </a:stretch>
         </p:blipFill>
         <p:spPr>
           <a:xfrm>
-            <a:off x="10817352" y="2715768"/>
+            <a:off x="10817352" y="2852928"/>
             <a:ext cx="411480" cy="411480"/>
           </a:xfrm>
           <a:prstGeom prst="rect">
@@ -2844,13 +2829,13 @@
       </p:pic>
       <p:sp>
         <p:nvSpPr>
-          <p:cNvPr id="17" name="Shape 12"/>
+          <p:cNvPr id="17" name="Shape 11"/>
           <p:cNvSpPr/>
           <p:nvPr/>
         </p:nvSpPr>
         <p:spPr>
           <a:xfrm>
-            <a:off x="4389120" y="3648456"/>
+            <a:off x="4389120" y="3785616"/>
             <a:ext cx="7159752" cy="1051560"/>
           </a:xfrm>
           <a:prstGeom prst="roundRect">
@@ -2878,13 +2863,13 @@
       </p:sp>
       <p:sp>
         <p:nvSpPr>
-          <p:cNvPr id="18" name="Shape 13"/>
+          <p:cNvPr id="18" name="Shape 12"/>
           <p:cNvSpPr/>
           <p:nvPr/>
         </p:nvSpPr>
         <p:spPr>
           <a:xfrm>
-            <a:off x="4663440" y="3899916"/>
+            <a:off x="4663440" y="4037076"/>
             <a:ext cx="548640" cy="548640"/>
           </a:xfrm>
           <a:prstGeom prst="ellipse">
@@ -2903,13 +2888,13 @@
       </p:sp>
       <p:sp>
         <p:nvSpPr>
-          <p:cNvPr id="19" name="Text 14"/>
+          <p:cNvPr id="19" name="Text 13"/>
           <p:cNvSpPr txBox="1"/>
           <p:nvPr/>
         </p:nvSpPr>
         <p:spPr>
           <a:xfrm>
-            <a:off x="4663440" y="3899916"/>
+            <a:off x="4663440" y="4037076"/>
             <a:ext cx="548640" cy="548640"/>
           </a:xfrm>
           <a:prstGeom prst="rect">
@@ -2942,13 +2927,13 @@
       </p:sp>
       <p:sp>
         <p:nvSpPr>
-          <p:cNvPr id="20" name="Text 15"/>
+          <p:cNvPr id="20" name="Text 14"/>
           <p:cNvSpPr txBox="1"/>
           <p:nvPr/>
         </p:nvSpPr>
         <p:spPr>
           <a:xfrm>
-            <a:off x="5440680" y="3648456"/>
+            <a:off x="5440680" y="3785616"/>
             <a:ext cx="5239512" cy="1051560"/>
           </a:xfrm>
           <a:prstGeom prst="rect">
@@ -2995,21 +2980,21 @@
       </p:sp>
       <p:pic>
         <p:nvPicPr>
-          <p:cNvPr id="21" name="Image 2" descr="preencoded.png">    </p:cNvPr>
+          <p:cNvPr id="21" name="Image 3" descr="preencoded.png">    </p:cNvPr>
           <p:cNvPicPr>
             <a:picLocks noChangeAspect="1"/>
           </p:cNvPicPr>
           <p:nvPr/>
         </p:nvPicPr>
         <p:blipFill>
-          <a:blip r:embed="rId3"/>
+          <a:blip r:embed="rId4"/>
           <a:stretch>
             <a:fillRect/>
           </a:stretch>
         </p:blipFill>
         <p:spPr>
           <a:xfrm>
-            <a:off x="10817352" y="3968496"/>
+            <a:off x="10817352" y="4105656"/>
             <a:ext cx="411480" cy="411480"/>
           </a:xfrm>
           <a:prstGeom prst="rect">
@@ -3019,13 +3004,13 @@
       </p:pic>
       <p:sp>
         <p:nvSpPr>
-          <p:cNvPr id="22" name="Shape 16"/>
+          <p:cNvPr id="22" name="Shape 15"/>
           <p:cNvSpPr/>
           <p:nvPr/>
         </p:nvSpPr>
         <p:spPr>
           <a:xfrm>
-            <a:off x="4389120" y="4992624"/>
+            <a:off x="4389120" y="5129784"/>
             <a:ext cx="7159752" cy="1097280"/>
           </a:xfrm>
           <a:prstGeom prst="roundRect">
@@ -3053,13 +3038,13 @@
       </p:sp>
       <p:sp>
         <p:nvSpPr>
-          <p:cNvPr id="23" name="Shape 17"/>
+          <p:cNvPr id="23" name="Shape 16"/>
           <p:cNvSpPr/>
           <p:nvPr/>
         </p:nvSpPr>
         <p:spPr>
           <a:xfrm>
-            <a:off x="4754880" y="5152644"/>
+            <a:off x="4754880" y="5289804"/>
             <a:ext cx="777240" cy="777240"/>
           </a:xfrm>
           <a:prstGeom prst="ellipse">
@@ -3078,21 +3063,21 @@
       </p:sp>
       <p:pic>
         <p:nvPicPr>
-          <p:cNvPr id="24" name="Image 3" descr="preencoded.png">    </p:cNvPr>
+          <p:cNvPr id="24" name="Image 4" descr="preencoded.png">    </p:cNvPr>
           <p:cNvPicPr>
             <a:picLocks noChangeAspect="1"/>
           </p:cNvPicPr>
           <p:nvPr/>
         </p:nvPicPr>
         <p:blipFill>
-          <a:blip r:embed="rId4"/>
+          <a:blip r:embed="rId5"/>
           <a:stretch>
             <a:fillRect/>
           </a:stretch>
         </p:blipFill>
         <p:spPr>
           <a:xfrm>
-            <a:off x="4964735" y="5362499"/>
+            <a:off x="4964735" y="5499659"/>
             <a:ext cx="357530" cy="357530"/>
           </a:xfrm>
           <a:prstGeom prst="rect">
@@ -3102,13 +3087,13 @@
       </p:pic>
       <p:sp>
         <p:nvSpPr>
-          <p:cNvPr id="25" name="Text 18"/>
+          <p:cNvPr id="25" name="Text 17"/>
           <p:cNvSpPr txBox="1"/>
           <p:nvPr/>
         </p:nvSpPr>
         <p:spPr>
           <a:xfrm>
-            <a:off x="5806440" y="4992624"/>
+            <a:off x="5806440" y="5129784"/>
             <a:ext cx="5422392" cy="1097280"/>
           </a:xfrm>
           <a:prstGeom prst="rect">
@@ -3174,16 +3159,40 @@
           <a:chExt cx="0" cy="0"/>
         </a:xfrm>
       </p:grpSpPr>
-      <p:sp>
-        <p:nvSpPr>
-          <p:cNvPr id="3" name="Text 0"/>
+      <p:pic>
+        <p:nvPicPr>
+          <p:cNvPr id="3" name="Image 0" descr="Breaking Barriers at work">    </p:cNvPr>
+          <p:cNvPicPr>
+            <a:picLocks noChangeAspect="1"/>
+          </p:cNvPicPr>
+          <p:nvPr/>
+        </p:nvPicPr>
+        <p:blipFill>
+          <a:blip r:embed="rId1"/>
+          <a:stretch>
+            <a:fillRect/>
+          </a:stretch>
+        </p:blipFill>
+        <p:spPr>
+          <a:xfrm>
+            <a:off x="640080" y="274320"/>
+            <a:ext cx="1188720" cy="542536"/>
+          </a:xfrm>
+          <a:prstGeom prst="rect">
+            <a:avLst/>
+          </a:prstGeom>
+        </p:spPr>
+      </p:pic>
+      <p:sp>
+        <p:nvSpPr>
+          <p:cNvPr id="4" name="Text 0"/>
           <p:cNvSpPr txBox="1"/>
           <p:nvPr/>
         </p:nvSpPr>
         <p:spPr>
           <a:xfrm>
-            <a:off x="640080" y="384048"/>
-            <a:ext cx="4572000" cy="274320"/>
+            <a:off x="7891272" y="384048"/>
+            <a:ext cx="3657600" cy="274320"/>
           </a:xfrm>
           <a:prstGeom prst="rect">
             <a:avLst/>
@@ -3195,86 +3204,47 @@
           <a:bodyPr wrap="square" lIns="0" tIns="0" rIns="0" bIns="0" rtlCol="0" anchor="ctr"/>
           <a:lstStyle/>
           <a:p>
-            <a:pPr indent="0" marL="0">
-              <a:buNone/>
-            </a:pPr>
-            <a:r>
-              <a:rPr lang="en-US" sz="1050" b="1" spc="300" kern="0" dirty="0">
-                <a:solidFill>
-                  <a:srgbClr val="C68C6C"/>
+            <a:pPr algn="r" indent="0" marL="0">
+              <a:buNone/>
+            </a:pPr>
+            <a:r>
+              <a:rPr lang="en-US" sz="1100" i="1" dirty="0">
+                <a:solidFill>
+                  <a:srgbClr val="8A6A55"/>
+                </a:solidFill>
+                <a:latin typeface="Source Serif Pro" pitchFamily="34" charset="0"/>
+                <a:ea typeface="Source Serif Pro" pitchFamily="34" charset="-122"/>
+                <a:cs typeface="Source Serif Pro" pitchFamily="34" charset="-120"/>
+              </a:rPr>
+              <a:t>by Flor Pérsico</a:t>
+            </a:r>
+            <a:pPr algn="r" indent="0" marL="0">
+              <a:buNone/>
+            </a:pPr>
+            <a:r>
+              <a:rPr lang="en-US" sz="1100" dirty="0">
+                <a:solidFill>
+                  <a:srgbClr val="8A6A55"/>
                 </a:solidFill>
                 <a:latin typeface="Open Sans" pitchFamily="34" charset="0"/>
                 <a:ea typeface="Open Sans" pitchFamily="34" charset="-122"/>
                 <a:cs typeface="Open Sans" pitchFamily="34" charset="-120"/>
               </a:rPr>
-              <a:t>BREAKING BARRIERS · AT WORK</a:t>
-            </a:r>
-            <a:endParaRPr lang="en-US" sz="1050" dirty="0"/>
-          </a:p>
-        </p:txBody>
-      </p:sp>
-      <p:sp>
-        <p:nvSpPr>
-          <p:cNvPr id="4" name="Text 1"/>
+              <a:t>   ·   03 / 09</a:t>
+            </a:r>
+            <a:endParaRPr lang="en-US" sz="1100" dirty="0"/>
+          </a:p>
+        </p:txBody>
+      </p:sp>
+      <p:sp>
+        <p:nvSpPr>
+          <p:cNvPr id="5" name="Text 1"/>
           <p:cNvSpPr txBox="1"/>
           <p:nvPr/>
         </p:nvSpPr>
         <p:spPr>
           <a:xfrm>
-            <a:off x="7891272" y="384048"/>
-            <a:ext cx="3657600" cy="274320"/>
-          </a:xfrm>
-          <a:prstGeom prst="rect">
-            <a:avLst/>
-          </a:prstGeom>
-          <a:noFill/>
-          <a:ln/>
-        </p:spPr>
-        <p:txBody>
-          <a:bodyPr wrap="square" lIns="0" tIns="0" rIns="0" bIns="0" rtlCol="0" anchor="ctr"/>
-          <a:lstStyle/>
-          <a:p>
-            <a:pPr algn="r" indent="0" marL="0">
-              <a:buNone/>
-            </a:pPr>
-            <a:r>
-              <a:rPr lang="en-US" sz="1100" i="1" dirty="0">
-                <a:solidFill>
-                  <a:srgbClr val="8A6A55"/>
-                </a:solidFill>
-                <a:latin typeface="Source Serif Pro" pitchFamily="34" charset="0"/>
-                <a:ea typeface="Source Serif Pro" pitchFamily="34" charset="-122"/>
-                <a:cs typeface="Source Serif Pro" pitchFamily="34" charset="-120"/>
-              </a:rPr>
-              <a:t>by Flor Pérsico</a:t>
-            </a:r>
-            <a:pPr algn="r" indent="0" marL="0">
-              <a:buNone/>
-            </a:pPr>
-            <a:r>
-              <a:rPr lang="en-US" sz="1100" dirty="0">
-                <a:solidFill>
-                  <a:srgbClr val="8A6A55"/>
-                </a:solidFill>
-                <a:latin typeface="Open Sans" pitchFamily="34" charset="0"/>
-                <a:ea typeface="Open Sans" pitchFamily="34" charset="-122"/>
-                <a:cs typeface="Open Sans" pitchFamily="34" charset="-120"/>
-              </a:rPr>
-              <a:t>   ·   03 / 09</a:t>
-            </a:r>
-            <a:endParaRPr lang="en-US" sz="1100" dirty="0"/>
-          </a:p>
-        </p:txBody>
-      </p:sp>
-      <p:sp>
-        <p:nvSpPr>
-          <p:cNvPr id="5" name="Text 2"/>
-          <p:cNvSpPr txBox="1"/>
-          <p:nvPr/>
-        </p:nvSpPr>
-        <p:spPr>
-          <a:xfrm>
-            <a:off x="640080" y="1097280"/>
+            <a:off x="640080" y="1280160"/>
             <a:ext cx="3429000" cy="1783080"/>
           </a:xfrm>
           <a:prstGeom prst="rect">
@@ -3310,13 +3280,13 @@
       </p:sp>
       <p:sp>
         <p:nvSpPr>
-          <p:cNvPr id="6" name="Text 3"/>
+          <p:cNvPr id="6" name="Text 2"/>
           <p:cNvSpPr txBox="1"/>
           <p:nvPr/>
         </p:nvSpPr>
         <p:spPr>
           <a:xfrm>
-            <a:off x="640080" y="2414016"/>
+            <a:off x="640080" y="2596896"/>
             <a:ext cx="3291840" cy="731520"/>
           </a:xfrm>
           <a:prstGeom prst="rect">
@@ -3349,13 +3319,13 @@
       </p:sp>
       <p:sp>
         <p:nvSpPr>
-          <p:cNvPr id="7" name="Shape 4"/>
+          <p:cNvPr id="7" name="Shape 3"/>
           <p:cNvSpPr/>
           <p:nvPr/>
         </p:nvSpPr>
         <p:spPr>
           <a:xfrm>
-            <a:off x="4389120" y="1143000"/>
+            <a:off x="4389120" y="1280160"/>
             <a:ext cx="3442716" cy="2331720"/>
           </a:xfrm>
           <a:prstGeom prst="roundRect">
@@ -3383,13 +3353,13 @@
       </p:sp>
       <p:sp>
         <p:nvSpPr>
-          <p:cNvPr id="8" name="Shape 5"/>
+          <p:cNvPr id="8" name="Shape 4"/>
           <p:cNvSpPr/>
           <p:nvPr/>
         </p:nvSpPr>
         <p:spPr>
           <a:xfrm>
-            <a:off x="4709160" y="1435608"/>
+            <a:off x="4709160" y="1572768"/>
             <a:ext cx="640080" cy="640080"/>
           </a:xfrm>
           <a:prstGeom prst="ellipse">
@@ -3408,21 +3378,21 @@
       </p:sp>
       <p:pic>
         <p:nvPicPr>
-          <p:cNvPr id="9" name="Image 0" descr="preencoded.png">    </p:cNvPr>
+          <p:cNvPr id="9" name="Image 1" descr="preencoded.png">    </p:cNvPr>
           <p:cNvPicPr>
             <a:picLocks noChangeAspect="1"/>
           </p:cNvPicPr>
           <p:nvPr/>
         </p:nvPicPr>
         <p:blipFill>
-          <a:blip r:embed="rId1"/>
+          <a:blip r:embed="rId2"/>
           <a:stretch>
             <a:fillRect/>
           </a:stretch>
         </p:blipFill>
         <p:spPr>
           <a:xfrm>
-            <a:off x="4881982" y="1608430"/>
+            <a:off x="4881982" y="1745590"/>
             <a:ext cx="294437" cy="294437"/>
           </a:xfrm>
           <a:prstGeom prst="rect">
@@ -3432,13 +3402,13 @@
       </p:pic>
       <p:sp>
         <p:nvSpPr>
-          <p:cNvPr id="10" name="Text 6"/>
+          <p:cNvPr id="10" name="Text 5"/>
           <p:cNvSpPr txBox="1"/>
           <p:nvPr/>
         </p:nvSpPr>
         <p:spPr>
           <a:xfrm>
-            <a:off x="4709160" y="2148840"/>
+            <a:off x="4709160" y="2286000"/>
             <a:ext cx="2894076" cy="502920"/>
           </a:xfrm>
           <a:prstGeom prst="rect">
@@ -3471,13 +3441,13 @@
       </p:sp>
       <p:sp>
         <p:nvSpPr>
-          <p:cNvPr id="11" name="Text 7"/>
+          <p:cNvPr id="11" name="Text 6"/>
           <p:cNvSpPr txBox="1"/>
           <p:nvPr/>
         </p:nvSpPr>
         <p:spPr>
           <a:xfrm>
-            <a:off x="4709160" y="2697480"/>
+            <a:off x="4709160" y="2834640"/>
             <a:ext cx="2894076" cy="640080"/>
           </a:xfrm>
           <a:prstGeom prst="rect">
@@ -3510,13 +3480,13 @@
       </p:sp>
       <p:sp>
         <p:nvSpPr>
-          <p:cNvPr id="12" name="Shape 8"/>
+          <p:cNvPr id="12" name="Shape 7"/>
           <p:cNvSpPr/>
           <p:nvPr/>
         </p:nvSpPr>
         <p:spPr>
           <a:xfrm>
-            <a:off x="8106156" y="1143000"/>
+            <a:off x="8106156" y="1280160"/>
             <a:ext cx="3442716" cy="2331720"/>
           </a:xfrm>
           <a:prstGeom prst="roundRect">
@@ -3544,13 +3514,13 @@
       </p:sp>
       <p:sp>
         <p:nvSpPr>
-          <p:cNvPr id="13" name="Shape 9"/>
+          <p:cNvPr id="13" name="Shape 8"/>
           <p:cNvSpPr/>
           <p:nvPr/>
         </p:nvSpPr>
         <p:spPr>
           <a:xfrm>
-            <a:off x="8426196" y="1435608"/>
+            <a:off x="8426196" y="1572768"/>
             <a:ext cx="640080" cy="640080"/>
           </a:xfrm>
           <a:prstGeom prst="ellipse">
@@ -3569,21 +3539,21 @@
       </p:sp>
       <p:pic>
         <p:nvPicPr>
-          <p:cNvPr id="14" name="Image 1" descr="preencoded.png">    </p:cNvPr>
+          <p:cNvPr id="14" name="Image 2" descr="preencoded.png">    </p:cNvPr>
           <p:cNvPicPr>
             <a:picLocks noChangeAspect="1"/>
           </p:cNvPicPr>
           <p:nvPr/>
         </p:nvPicPr>
         <p:blipFill>
-          <a:blip r:embed="rId2"/>
+          <a:blip r:embed="rId3"/>
           <a:stretch>
             <a:fillRect/>
           </a:stretch>
         </p:blipFill>
         <p:spPr>
           <a:xfrm>
-            <a:off x="8599018" y="1608430"/>
+            <a:off x="8599018" y="1745590"/>
             <a:ext cx="294437" cy="294437"/>
           </a:xfrm>
           <a:prstGeom prst="rect">
@@ -3593,13 +3563,13 @@
       </p:pic>
       <p:sp>
         <p:nvSpPr>
-          <p:cNvPr id="15" name="Text 10"/>
+          <p:cNvPr id="15" name="Text 9"/>
           <p:cNvSpPr txBox="1"/>
           <p:nvPr/>
         </p:nvSpPr>
         <p:spPr>
           <a:xfrm>
-            <a:off x="8426196" y="2148840"/>
+            <a:off x="8426196" y="2286000"/>
             <a:ext cx="2894076" cy="502920"/>
           </a:xfrm>
           <a:prstGeom prst="rect">
@@ -3632,13 +3602,13 @@
       </p:sp>
       <p:sp>
         <p:nvSpPr>
-          <p:cNvPr id="16" name="Text 11"/>
+          <p:cNvPr id="16" name="Text 10"/>
           <p:cNvSpPr txBox="1"/>
           <p:nvPr/>
         </p:nvSpPr>
         <p:spPr>
           <a:xfrm>
-            <a:off x="8426196" y="2697480"/>
+            <a:off x="8426196" y="2834640"/>
             <a:ext cx="2894076" cy="640080"/>
           </a:xfrm>
           <a:prstGeom prst="rect">
@@ -3671,13 +3641,13 @@
       </p:sp>
       <p:sp>
         <p:nvSpPr>
-          <p:cNvPr id="17" name="Shape 12"/>
+          <p:cNvPr id="17" name="Shape 11"/>
           <p:cNvSpPr/>
           <p:nvPr/>
         </p:nvSpPr>
         <p:spPr>
           <a:xfrm>
-            <a:off x="4389120" y="3749040"/>
+            <a:off x="4389120" y="3886200"/>
             <a:ext cx="3442716" cy="2331720"/>
           </a:xfrm>
           <a:prstGeom prst="roundRect">
@@ -3705,13 +3675,13 @@
       </p:sp>
       <p:sp>
         <p:nvSpPr>
-          <p:cNvPr id="18" name="Shape 13"/>
+          <p:cNvPr id="18" name="Shape 12"/>
           <p:cNvSpPr/>
           <p:nvPr/>
         </p:nvSpPr>
         <p:spPr>
           <a:xfrm>
-            <a:off x="4709160" y="4041648"/>
+            <a:off x="4709160" y="4178808"/>
             <a:ext cx="640080" cy="640080"/>
           </a:xfrm>
           <a:prstGeom prst="ellipse">
@@ -3730,21 +3700,21 @@
       </p:sp>
       <p:pic>
         <p:nvPicPr>
-          <p:cNvPr id="19" name="Image 2" descr="preencoded.png">    </p:cNvPr>
+          <p:cNvPr id="19" name="Image 3" descr="preencoded.png">    </p:cNvPr>
           <p:cNvPicPr>
             <a:picLocks noChangeAspect="1"/>
           </p:cNvPicPr>
           <p:nvPr/>
         </p:nvPicPr>
         <p:blipFill>
-          <a:blip r:embed="rId3"/>
+          <a:blip r:embed="rId4"/>
           <a:stretch>
             <a:fillRect/>
           </a:stretch>
         </p:blipFill>
         <p:spPr>
           <a:xfrm>
-            <a:off x="4881982" y="4214470"/>
+            <a:off x="4881982" y="4351630"/>
             <a:ext cx="294437" cy="294437"/>
           </a:xfrm>
           <a:prstGeom prst="rect">
@@ -3754,13 +3724,13 @@
       </p:pic>
       <p:sp>
         <p:nvSpPr>
-          <p:cNvPr id="20" name="Text 14"/>
+          <p:cNvPr id="20" name="Text 13"/>
           <p:cNvSpPr txBox="1"/>
           <p:nvPr/>
         </p:nvSpPr>
         <p:spPr>
           <a:xfrm>
-            <a:off x="4709160" y="4754880"/>
+            <a:off x="4709160" y="4892040"/>
             <a:ext cx="2894076" cy="502920"/>
           </a:xfrm>
           <a:prstGeom prst="rect">
@@ -3793,13 +3763,13 @@
       </p:sp>
       <p:sp>
         <p:nvSpPr>
-          <p:cNvPr id="21" name="Text 15"/>
+          <p:cNvPr id="21" name="Text 14"/>
           <p:cNvSpPr txBox="1"/>
           <p:nvPr/>
         </p:nvSpPr>
         <p:spPr>
           <a:xfrm>
-            <a:off x="4709160" y="5303520"/>
+            <a:off x="4709160" y="5440680"/>
             <a:ext cx="2894076" cy="640080"/>
           </a:xfrm>
           <a:prstGeom prst="rect">
@@ -3832,13 +3802,13 @@
       </p:sp>
       <p:sp>
         <p:nvSpPr>
-          <p:cNvPr id="22" name="Shape 16"/>
+          <p:cNvPr id="22" name="Shape 15"/>
           <p:cNvSpPr/>
           <p:nvPr/>
         </p:nvSpPr>
         <p:spPr>
           <a:xfrm>
-            <a:off x="8106156" y="3749040"/>
+            <a:off x="8106156" y="3886200"/>
             <a:ext cx="3442716" cy="2331720"/>
           </a:xfrm>
           <a:prstGeom prst="roundRect">
@@ -3866,13 +3836,13 @@
       </p:sp>
       <p:sp>
         <p:nvSpPr>
-          <p:cNvPr id="23" name="Shape 17"/>
+          <p:cNvPr id="23" name="Shape 16"/>
           <p:cNvSpPr/>
           <p:nvPr/>
         </p:nvSpPr>
         <p:spPr>
           <a:xfrm>
-            <a:off x="8426196" y="4041648"/>
+            <a:off x="8426196" y="4178808"/>
             <a:ext cx="640080" cy="640080"/>
           </a:xfrm>
           <a:prstGeom prst="ellipse">
@@ -3891,21 +3861,21 @@
       </p:sp>
       <p:pic>
         <p:nvPicPr>
-          <p:cNvPr id="24" name="Image 3" descr="preencoded.png">    </p:cNvPr>
+          <p:cNvPr id="24" name="Image 4" descr="preencoded.png">    </p:cNvPr>
           <p:cNvPicPr>
             <a:picLocks noChangeAspect="1"/>
           </p:cNvPicPr>
           <p:nvPr/>
         </p:nvPicPr>
         <p:blipFill>
-          <a:blip r:embed="rId4"/>
+          <a:blip r:embed="rId5"/>
           <a:stretch>
             <a:fillRect/>
           </a:stretch>
         </p:blipFill>
         <p:spPr>
           <a:xfrm>
-            <a:off x="8599018" y="4214470"/>
+            <a:off x="8599018" y="4351630"/>
             <a:ext cx="294437" cy="294437"/>
           </a:xfrm>
           <a:prstGeom prst="rect">
@@ -3915,13 +3885,13 @@
       </p:pic>
       <p:sp>
         <p:nvSpPr>
-          <p:cNvPr id="25" name="Text 18"/>
+          <p:cNvPr id="25" name="Text 17"/>
           <p:cNvSpPr txBox="1"/>
           <p:nvPr/>
         </p:nvSpPr>
         <p:spPr>
           <a:xfrm>
-            <a:off x="8426196" y="4754880"/>
+            <a:off x="8426196" y="4892040"/>
             <a:ext cx="2894076" cy="502920"/>
           </a:xfrm>
           <a:prstGeom prst="rect">
@@ -3954,13 +3924,13 @@
       </p:sp>
       <p:sp>
         <p:nvSpPr>
-          <p:cNvPr id="26" name="Text 19"/>
+          <p:cNvPr id="26" name="Text 18"/>
           <p:cNvSpPr txBox="1"/>
           <p:nvPr/>
         </p:nvSpPr>
         <p:spPr>
           <a:xfrm>
-            <a:off x="8426196" y="5303520"/>
+            <a:off x="8426196" y="5440680"/>
             <a:ext cx="2894076" cy="640080"/>
           </a:xfrm>
           <a:prstGeom prst="rect">
@@ -4023,16 +3993,40 @@
           <a:chExt cx="0" cy="0"/>
         </a:xfrm>
       </p:grpSpPr>
-      <p:sp>
-        <p:nvSpPr>
-          <p:cNvPr id="3" name="Text 0"/>
+      <p:pic>
+        <p:nvPicPr>
+          <p:cNvPr id="3" name="Image 0" descr="Breaking Barriers at work">    </p:cNvPr>
+          <p:cNvPicPr>
+            <a:picLocks noChangeAspect="1"/>
+          </p:cNvPicPr>
+          <p:nvPr/>
+        </p:nvPicPr>
+        <p:blipFill>
+          <a:blip r:embed="rId1"/>
+          <a:stretch>
+            <a:fillRect/>
+          </a:stretch>
+        </p:blipFill>
+        <p:spPr>
+          <a:xfrm>
+            <a:off x="640080" y="274320"/>
+            <a:ext cx="1188720" cy="542536"/>
+          </a:xfrm>
+          <a:prstGeom prst="rect">
+            <a:avLst/>
+          </a:prstGeom>
+        </p:spPr>
+      </p:pic>
+      <p:sp>
+        <p:nvSpPr>
+          <p:cNvPr id="4" name="Text 0"/>
           <p:cNvSpPr txBox="1"/>
           <p:nvPr/>
         </p:nvSpPr>
         <p:spPr>
           <a:xfrm>
-            <a:off x="640080" y="384048"/>
-            <a:ext cx="4572000" cy="274320"/>
+            <a:off x="7891272" y="384048"/>
+            <a:ext cx="3657600" cy="274320"/>
           </a:xfrm>
           <a:prstGeom prst="rect">
             <a:avLst/>
@@ -4044,86 +4038,47 @@
           <a:bodyPr wrap="square" lIns="0" tIns="0" rIns="0" bIns="0" rtlCol="0" anchor="ctr"/>
           <a:lstStyle/>
           <a:p>
-            <a:pPr indent="0" marL="0">
-              <a:buNone/>
-            </a:pPr>
-            <a:r>
-              <a:rPr lang="en-US" sz="1050" b="1" spc="300" kern="0" dirty="0">
-                <a:solidFill>
-                  <a:srgbClr val="C68C6C"/>
+            <a:pPr algn="r" indent="0" marL="0">
+              <a:buNone/>
+            </a:pPr>
+            <a:r>
+              <a:rPr lang="en-US" sz="1100" i="1" dirty="0">
+                <a:solidFill>
+                  <a:srgbClr val="8A6A55"/>
+                </a:solidFill>
+                <a:latin typeface="Source Serif Pro" pitchFamily="34" charset="0"/>
+                <a:ea typeface="Source Serif Pro" pitchFamily="34" charset="-122"/>
+                <a:cs typeface="Source Serif Pro" pitchFamily="34" charset="-120"/>
+              </a:rPr>
+              <a:t>by Flor Pérsico</a:t>
+            </a:r>
+            <a:pPr algn="r" indent="0" marL="0">
+              <a:buNone/>
+            </a:pPr>
+            <a:r>
+              <a:rPr lang="en-US" sz="1100" dirty="0">
+                <a:solidFill>
+                  <a:srgbClr val="8A6A55"/>
                 </a:solidFill>
                 <a:latin typeface="Open Sans" pitchFamily="34" charset="0"/>
                 <a:ea typeface="Open Sans" pitchFamily="34" charset="-122"/>
                 <a:cs typeface="Open Sans" pitchFamily="34" charset="-120"/>
               </a:rPr>
-              <a:t>BREAKING BARRIERS · AT WORK</a:t>
-            </a:r>
-            <a:endParaRPr lang="en-US" sz="1050" dirty="0"/>
-          </a:p>
-        </p:txBody>
-      </p:sp>
-      <p:sp>
-        <p:nvSpPr>
-          <p:cNvPr id="4" name="Text 1"/>
+              <a:t>   ·   04 / 09</a:t>
+            </a:r>
+            <a:endParaRPr lang="en-US" sz="1100" dirty="0"/>
+          </a:p>
+        </p:txBody>
+      </p:sp>
+      <p:sp>
+        <p:nvSpPr>
+          <p:cNvPr id="5" name="Text 1"/>
           <p:cNvSpPr txBox="1"/>
           <p:nvPr/>
         </p:nvSpPr>
         <p:spPr>
           <a:xfrm>
-            <a:off x="7891272" y="384048"/>
-            <a:ext cx="3657600" cy="274320"/>
-          </a:xfrm>
-          <a:prstGeom prst="rect">
-            <a:avLst/>
-          </a:prstGeom>
-          <a:noFill/>
-          <a:ln/>
-        </p:spPr>
-        <p:txBody>
-          <a:bodyPr wrap="square" lIns="0" tIns="0" rIns="0" bIns="0" rtlCol="0" anchor="ctr"/>
-          <a:lstStyle/>
-          <a:p>
-            <a:pPr algn="r" indent="0" marL="0">
-              <a:buNone/>
-            </a:pPr>
-            <a:r>
-              <a:rPr lang="en-US" sz="1100" i="1" dirty="0">
-                <a:solidFill>
-                  <a:srgbClr val="8A6A55"/>
-                </a:solidFill>
-                <a:latin typeface="Source Serif Pro" pitchFamily="34" charset="0"/>
-                <a:ea typeface="Source Serif Pro" pitchFamily="34" charset="-122"/>
-                <a:cs typeface="Source Serif Pro" pitchFamily="34" charset="-120"/>
-              </a:rPr>
-              <a:t>by Flor Pérsico</a:t>
-            </a:r>
-            <a:pPr algn="r" indent="0" marL="0">
-              <a:buNone/>
-            </a:pPr>
-            <a:r>
-              <a:rPr lang="en-US" sz="1100" dirty="0">
-                <a:solidFill>
-                  <a:srgbClr val="8A6A55"/>
-                </a:solidFill>
-                <a:latin typeface="Open Sans" pitchFamily="34" charset="0"/>
-                <a:ea typeface="Open Sans" pitchFamily="34" charset="-122"/>
-                <a:cs typeface="Open Sans" pitchFamily="34" charset="-120"/>
-              </a:rPr>
-              <a:t>   ·   04 / 09</a:t>
-            </a:r>
-            <a:endParaRPr lang="en-US" sz="1100" dirty="0"/>
-          </a:p>
-        </p:txBody>
-      </p:sp>
-      <p:sp>
-        <p:nvSpPr>
-          <p:cNvPr id="5" name="Text 2"/>
-          <p:cNvSpPr txBox="1"/>
-          <p:nvPr/>
-        </p:nvSpPr>
-        <p:spPr>
-          <a:xfrm>
-            <a:off x="640080" y="1097280"/>
+            <a:off x="640080" y="1280160"/>
             <a:ext cx="3429000" cy="1783080"/>
           </a:xfrm>
           <a:prstGeom prst="rect">
@@ -4159,13 +4114,13 @@
       </p:sp>
       <p:sp>
         <p:nvSpPr>
-          <p:cNvPr id="6" name="Text 3"/>
+          <p:cNvPr id="6" name="Text 2"/>
           <p:cNvSpPr txBox="1"/>
           <p:nvPr/>
         </p:nvSpPr>
         <p:spPr>
           <a:xfrm>
-            <a:off x="640080" y="2414016"/>
+            <a:off x="640080" y="2596896"/>
             <a:ext cx="3291840" cy="731520"/>
           </a:xfrm>
           <a:prstGeom prst="rect">
@@ -4198,13 +4153,13 @@
       </p:sp>
       <p:sp>
         <p:nvSpPr>
-          <p:cNvPr id="7" name="Shape 4"/>
+          <p:cNvPr id="7" name="Shape 3"/>
           <p:cNvSpPr/>
           <p:nvPr/>
         </p:nvSpPr>
         <p:spPr>
           <a:xfrm>
-            <a:off x="4389120" y="1143000"/>
+            <a:off x="4389120" y="1280160"/>
             <a:ext cx="2203704" cy="4023360"/>
           </a:xfrm>
           <a:prstGeom prst="roundRect">
@@ -4232,13 +4187,13 @@
       </p:sp>
       <p:sp>
         <p:nvSpPr>
-          <p:cNvPr id="8" name="Shape 5"/>
+          <p:cNvPr id="8" name="Shape 4"/>
           <p:cNvSpPr/>
           <p:nvPr/>
         </p:nvSpPr>
         <p:spPr>
           <a:xfrm>
-            <a:off x="4389120" y="1143000"/>
+            <a:off x="4389120" y="1280160"/>
             <a:ext cx="2203704" cy="1600200"/>
           </a:xfrm>
           <a:prstGeom prst="roundRect">
@@ -4259,13 +4214,13 @@
       </p:sp>
       <p:sp>
         <p:nvSpPr>
-          <p:cNvPr id="9" name="Shape 6"/>
+          <p:cNvPr id="9" name="Shape 5"/>
           <p:cNvSpPr/>
           <p:nvPr/>
         </p:nvSpPr>
         <p:spPr>
           <a:xfrm>
-            <a:off x="4389120" y="2468880"/>
+            <a:off x="4389120" y="2606040"/>
             <a:ext cx="2203704" cy="274320"/>
           </a:xfrm>
           <a:prstGeom prst="rect">
@@ -4284,21 +4239,21 @@
       </p:sp>
       <p:pic>
         <p:nvPicPr>
-          <p:cNvPr id="10" name="Image 0" descr="preencoded.png">    </p:cNvPr>
+          <p:cNvPr id="10" name="Image 1" descr="preencoded.png">    </p:cNvPr>
           <p:cNvPicPr>
             <a:picLocks noChangeAspect="1"/>
           </p:cNvPicPr>
           <p:nvPr/>
         </p:nvPicPr>
         <p:blipFill>
-          <a:blip r:embed="rId1"/>
+          <a:blip r:embed="rId2"/>
           <a:stretch>
             <a:fillRect/>
           </a:stretch>
         </p:blipFill>
         <p:spPr>
           <a:xfrm>
-            <a:off x="4663440" y="1399032"/>
+            <a:off x="4663440" y="1536192"/>
             <a:ext cx="365760" cy="365760"/>
           </a:xfrm>
           <a:prstGeom prst="rect">
@@ -4308,13 +4263,13 @@
       </p:pic>
       <p:sp>
         <p:nvSpPr>
-          <p:cNvPr id="11" name="Text 7"/>
+          <p:cNvPr id="11" name="Text 6"/>
           <p:cNvSpPr txBox="1"/>
           <p:nvPr/>
         </p:nvSpPr>
         <p:spPr>
           <a:xfrm>
-            <a:off x="4663440" y="1828800"/>
+            <a:off x="4663440" y="1965960"/>
             <a:ext cx="1746504" cy="548640"/>
           </a:xfrm>
           <a:prstGeom prst="rect">
@@ -4350,13 +4305,13 @@
       </p:sp>
       <p:sp>
         <p:nvSpPr>
-          <p:cNvPr id="12" name="Text 8"/>
+          <p:cNvPr id="12" name="Text 7"/>
           <p:cNvSpPr txBox="1"/>
           <p:nvPr/>
         </p:nvSpPr>
         <p:spPr>
           <a:xfrm>
-            <a:off x="4663440" y="2377440"/>
+            <a:off x="4663440" y="2514600"/>
             <a:ext cx="1746504" cy="256032"/>
           </a:xfrm>
           <a:prstGeom prst="rect">
@@ -4389,13 +4344,13 @@
       </p:sp>
       <p:sp>
         <p:nvSpPr>
-          <p:cNvPr id="13" name="Text 9"/>
+          <p:cNvPr id="13" name="Text 8"/>
           <p:cNvSpPr txBox="1"/>
           <p:nvPr/>
         </p:nvSpPr>
         <p:spPr>
           <a:xfrm>
-            <a:off x="4617720" y="2971800"/>
+            <a:off x="4617720" y="3108960"/>
             <a:ext cx="1792224" cy="2057400"/>
           </a:xfrm>
           <a:prstGeom prst="rect">
@@ -4516,13 +4471,13 @@
       </p:sp>
       <p:sp>
         <p:nvSpPr>
-          <p:cNvPr id="14" name="Shape 10"/>
+          <p:cNvPr id="14" name="Shape 9"/>
           <p:cNvSpPr/>
           <p:nvPr/>
         </p:nvSpPr>
         <p:spPr>
           <a:xfrm>
-            <a:off x="6867144" y="1143000"/>
+            <a:off x="6867144" y="1280160"/>
             <a:ext cx="2203704" cy="4023360"/>
           </a:xfrm>
           <a:prstGeom prst="roundRect">
@@ -4550,13 +4505,13 @@
       </p:sp>
       <p:sp>
         <p:nvSpPr>
-          <p:cNvPr id="15" name="Shape 11"/>
+          <p:cNvPr id="15" name="Shape 10"/>
           <p:cNvSpPr/>
           <p:nvPr/>
         </p:nvSpPr>
         <p:spPr>
           <a:xfrm>
-            <a:off x="6867144" y="1143000"/>
+            <a:off x="6867144" y="1280160"/>
             <a:ext cx="2203704" cy="1600200"/>
           </a:xfrm>
           <a:prstGeom prst="roundRect">
@@ -4577,13 +4532,13 @@
       </p:sp>
       <p:sp>
         <p:nvSpPr>
-          <p:cNvPr id="16" name="Shape 12"/>
+          <p:cNvPr id="16" name="Shape 11"/>
           <p:cNvSpPr/>
           <p:nvPr/>
         </p:nvSpPr>
         <p:spPr>
           <a:xfrm>
-            <a:off x="6867144" y="2468880"/>
+            <a:off x="6867144" y="2606040"/>
             <a:ext cx="2203704" cy="274320"/>
           </a:xfrm>
           <a:prstGeom prst="rect">
@@ -4602,21 +4557,21 @@
       </p:sp>
       <p:pic>
         <p:nvPicPr>
-          <p:cNvPr id="17" name="Image 1" descr="preencoded.png">    </p:cNvPr>
+          <p:cNvPr id="17" name="Image 2" descr="preencoded.png">    </p:cNvPr>
           <p:cNvPicPr>
             <a:picLocks noChangeAspect="1"/>
           </p:cNvPicPr>
           <p:nvPr/>
         </p:nvPicPr>
         <p:blipFill>
-          <a:blip r:embed="rId2"/>
+          <a:blip r:embed="rId3"/>
           <a:stretch>
             <a:fillRect/>
           </a:stretch>
         </p:blipFill>
         <p:spPr>
           <a:xfrm>
-            <a:off x="7141464" y="1399032"/>
+            <a:off x="7141464" y="1536192"/>
             <a:ext cx="365760" cy="365760"/>
           </a:xfrm>
           <a:prstGeom prst="rect">
@@ -4626,13 +4581,13 @@
       </p:pic>
       <p:sp>
         <p:nvSpPr>
-          <p:cNvPr id="18" name="Text 13"/>
+          <p:cNvPr id="18" name="Text 12"/>
           <p:cNvSpPr txBox="1"/>
           <p:nvPr/>
         </p:nvSpPr>
         <p:spPr>
           <a:xfrm>
-            <a:off x="7141464" y="1828800"/>
+            <a:off x="7141464" y="1965960"/>
             <a:ext cx="1746504" cy="548640"/>
           </a:xfrm>
           <a:prstGeom prst="rect">
@@ -4668,13 +4623,13 @@
       </p:sp>
       <p:sp>
         <p:nvSpPr>
-          <p:cNvPr id="19" name="Text 14"/>
+          <p:cNvPr id="19" name="Text 13"/>
           <p:cNvSpPr txBox="1"/>
           <p:nvPr/>
         </p:nvSpPr>
         <p:spPr>
           <a:xfrm>
-            <a:off x="7141464" y="2377440"/>
+            <a:off x="7141464" y="2514600"/>
             <a:ext cx="1746504" cy="256032"/>
           </a:xfrm>
           <a:prstGeom prst="rect">
@@ -4707,13 +4662,13 @@
       </p:sp>
       <p:sp>
         <p:nvSpPr>
-          <p:cNvPr id="20" name="Text 15"/>
+          <p:cNvPr id="20" name="Text 14"/>
           <p:cNvSpPr txBox="1"/>
           <p:nvPr/>
         </p:nvSpPr>
         <p:spPr>
           <a:xfrm>
-            <a:off x="7095744" y="2971800"/>
+            <a:off x="7095744" y="3108960"/>
             <a:ext cx="1792224" cy="2057400"/>
           </a:xfrm>
           <a:prstGeom prst="rect">
@@ -4771,13 +4726,13 @@
       </p:sp>
       <p:sp>
         <p:nvSpPr>
-          <p:cNvPr id="21" name="Shape 16"/>
+          <p:cNvPr id="21" name="Shape 15"/>
           <p:cNvSpPr/>
           <p:nvPr/>
         </p:nvSpPr>
         <p:spPr>
           <a:xfrm>
-            <a:off x="9345168" y="1143000"/>
+            <a:off x="9345168" y="1280160"/>
             <a:ext cx="2203704" cy="4023360"/>
           </a:xfrm>
           <a:prstGeom prst="roundRect">
@@ -4805,13 +4760,13 @@
       </p:sp>
       <p:sp>
         <p:nvSpPr>
-          <p:cNvPr id="22" name="Shape 17"/>
+          <p:cNvPr id="22" name="Shape 16"/>
           <p:cNvSpPr/>
           <p:nvPr/>
         </p:nvSpPr>
         <p:spPr>
           <a:xfrm>
-            <a:off x="9345168" y="1143000"/>
+            <a:off x="9345168" y="1280160"/>
             <a:ext cx="2203704" cy="1600200"/>
           </a:xfrm>
           <a:prstGeom prst="roundRect">
@@ -4832,13 +4787,13 @@
       </p:sp>
       <p:sp>
         <p:nvSpPr>
-          <p:cNvPr id="23" name="Shape 18"/>
+          <p:cNvPr id="23" name="Shape 17"/>
           <p:cNvSpPr/>
           <p:nvPr/>
         </p:nvSpPr>
         <p:spPr>
           <a:xfrm>
-            <a:off x="9345168" y="2468880"/>
+            <a:off x="9345168" y="2606040"/>
             <a:ext cx="2203704" cy="274320"/>
           </a:xfrm>
           <a:prstGeom prst="rect">
@@ -4857,21 +4812,21 @@
       </p:sp>
       <p:pic>
         <p:nvPicPr>
-          <p:cNvPr id="24" name="Image 2" descr="preencoded.png">    </p:cNvPr>
+          <p:cNvPr id="24" name="Image 3" descr="preencoded.png">    </p:cNvPr>
           <p:cNvPicPr>
             <a:picLocks noChangeAspect="1"/>
           </p:cNvPicPr>
           <p:nvPr/>
         </p:nvPicPr>
         <p:blipFill>
-          <a:blip r:embed="rId3"/>
+          <a:blip r:embed="rId4"/>
           <a:stretch>
             <a:fillRect/>
           </a:stretch>
         </p:blipFill>
         <p:spPr>
           <a:xfrm>
-            <a:off x="9619488" y="1399032"/>
+            <a:off x="9619488" y="1536192"/>
             <a:ext cx="365760" cy="365760"/>
           </a:xfrm>
           <a:prstGeom prst="rect">
@@ -4881,13 +4836,13 @@
       </p:pic>
       <p:sp>
         <p:nvSpPr>
-          <p:cNvPr id="25" name="Text 19"/>
+          <p:cNvPr id="25" name="Text 18"/>
           <p:cNvSpPr txBox="1"/>
           <p:nvPr/>
         </p:nvSpPr>
         <p:spPr>
           <a:xfrm>
-            <a:off x="9619488" y="1828800"/>
+            <a:off x="9619488" y="1965960"/>
             <a:ext cx="1746504" cy="548640"/>
           </a:xfrm>
           <a:prstGeom prst="rect">
@@ -4923,13 +4878,13 @@
       </p:sp>
       <p:sp>
         <p:nvSpPr>
-          <p:cNvPr id="26" name="Text 20"/>
+          <p:cNvPr id="26" name="Text 19"/>
           <p:cNvSpPr txBox="1"/>
           <p:nvPr/>
         </p:nvSpPr>
         <p:spPr>
           <a:xfrm>
-            <a:off x="9619488" y="2377440"/>
+            <a:off x="9619488" y="2514600"/>
             <a:ext cx="1746504" cy="256032"/>
           </a:xfrm>
           <a:prstGeom prst="rect">
@@ -4962,13 +4917,13 @@
       </p:sp>
       <p:sp>
         <p:nvSpPr>
-          <p:cNvPr id="27" name="Text 21"/>
+          <p:cNvPr id="27" name="Text 20"/>
           <p:cNvSpPr txBox="1"/>
           <p:nvPr/>
         </p:nvSpPr>
         <p:spPr>
           <a:xfrm>
-            <a:off x="9573768" y="2971800"/>
+            <a:off x="9573768" y="3108960"/>
             <a:ext cx="1792224" cy="2057400"/>
           </a:xfrm>
           <a:prstGeom prst="rect">
@@ -5035,16 +4990,40 @@
           <a:chExt cx="0" cy="0"/>
         </a:xfrm>
       </p:grpSpPr>
-      <p:sp>
-        <p:nvSpPr>
-          <p:cNvPr id="3" name="Text 0"/>
+      <p:pic>
+        <p:nvPicPr>
+          <p:cNvPr id="3" name="Image 0" descr="Breaking Barriers at work">    </p:cNvPr>
+          <p:cNvPicPr>
+            <a:picLocks noChangeAspect="1"/>
+          </p:cNvPicPr>
+          <p:nvPr/>
+        </p:nvPicPr>
+        <p:blipFill>
+          <a:blip r:embed="rId1"/>
+          <a:stretch>
+            <a:fillRect/>
+          </a:stretch>
+        </p:blipFill>
+        <p:spPr>
+          <a:xfrm>
+            <a:off x="640080" y="274320"/>
+            <a:ext cx="1188720" cy="542536"/>
+          </a:xfrm>
+          <a:prstGeom prst="rect">
+            <a:avLst/>
+          </a:prstGeom>
+        </p:spPr>
+      </p:pic>
+      <p:sp>
+        <p:nvSpPr>
+          <p:cNvPr id="4" name="Text 0"/>
           <p:cNvSpPr txBox="1"/>
           <p:nvPr/>
         </p:nvSpPr>
         <p:spPr>
           <a:xfrm>
-            <a:off x="640080" y="384048"/>
-            <a:ext cx="4572000" cy="274320"/>
+            <a:off x="7891272" y="384048"/>
+            <a:ext cx="3657600" cy="274320"/>
           </a:xfrm>
           <a:prstGeom prst="rect">
             <a:avLst/>
@@ -5056,86 +5035,47 @@
           <a:bodyPr wrap="square" lIns="0" tIns="0" rIns="0" bIns="0" rtlCol="0" anchor="ctr"/>
           <a:lstStyle/>
           <a:p>
-            <a:pPr indent="0" marL="0">
-              <a:buNone/>
-            </a:pPr>
-            <a:r>
-              <a:rPr lang="en-US" sz="1050" b="1" spc="300" kern="0" dirty="0">
-                <a:solidFill>
-                  <a:srgbClr val="C68C6C"/>
+            <a:pPr algn="r" indent="0" marL="0">
+              <a:buNone/>
+            </a:pPr>
+            <a:r>
+              <a:rPr lang="en-US" sz="1100" i="1" dirty="0">
+                <a:solidFill>
+                  <a:srgbClr val="8A6A55"/>
+                </a:solidFill>
+                <a:latin typeface="Source Serif Pro" pitchFamily="34" charset="0"/>
+                <a:ea typeface="Source Serif Pro" pitchFamily="34" charset="-122"/>
+                <a:cs typeface="Source Serif Pro" pitchFamily="34" charset="-120"/>
+              </a:rPr>
+              <a:t>by Flor Pérsico</a:t>
+            </a:r>
+            <a:pPr algn="r" indent="0" marL="0">
+              <a:buNone/>
+            </a:pPr>
+            <a:r>
+              <a:rPr lang="en-US" sz="1100" dirty="0">
+                <a:solidFill>
+                  <a:srgbClr val="8A6A55"/>
                 </a:solidFill>
                 <a:latin typeface="Open Sans" pitchFamily="34" charset="0"/>
                 <a:ea typeface="Open Sans" pitchFamily="34" charset="-122"/>
                 <a:cs typeface="Open Sans" pitchFamily="34" charset="-120"/>
               </a:rPr>
-              <a:t>BREAKING BARRIERS · AT WORK</a:t>
-            </a:r>
-            <a:endParaRPr lang="en-US" sz="1050" dirty="0"/>
-          </a:p>
-        </p:txBody>
-      </p:sp>
-      <p:sp>
-        <p:nvSpPr>
-          <p:cNvPr id="4" name="Text 1"/>
+              <a:t>   ·   05 / 09</a:t>
+            </a:r>
+            <a:endParaRPr lang="en-US" sz="1100" dirty="0"/>
+          </a:p>
+        </p:txBody>
+      </p:sp>
+      <p:sp>
+        <p:nvSpPr>
+          <p:cNvPr id="5" name="Text 1"/>
           <p:cNvSpPr txBox="1"/>
           <p:nvPr/>
         </p:nvSpPr>
         <p:spPr>
           <a:xfrm>
-            <a:off x="7891272" y="384048"/>
-            <a:ext cx="3657600" cy="274320"/>
-          </a:xfrm>
-          <a:prstGeom prst="rect">
-            <a:avLst/>
-          </a:prstGeom>
-          <a:noFill/>
-          <a:ln/>
-        </p:spPr>
-        <p:txBody>
-          <a:bodyPr wrap="square" lIns="0" tIns="0" rIns="0" bIns="0" rtlCol="0" anchor="ctr"/>
-          <a:lstStyle/>
-          <a:p>
-            <a:pPr algn="r" indent="0" marL="0">
-              <a:buNone/>
-            </a:pPr>
-            <a:r>
-              <a:rPr lang="en-US" sz="1100" i="1" dirty="0">
-                <a:solidFill>
-                  <a:srgbClr val="8A6A55"/>
-                </a:solidFill>
-                <a:latin typeface="Source Serif Pro" pitchFamily="34" charset="0"/>
-                <a:ea typeface="Source Serif Pro" pitchFamily="34" charset="-122"/>
-                <a:cs typeface="Source Serif Pro" pitchFamily="34" charset="-120"/>
-              </a:rPr>
-              <a:t>by Flor Pérsico</a:t>
-            </a:r>
-            <a:pPr algn="r" indent="0" marL="0">
-              <a:buNone/>
-            </a:pPr>
-            <a:r>
-              <a:rPr lang="en-US" sz="1100" dirty="0">
-                <a:solidFill>
-                  <a:srgbClr val="8A6A55"/>
-                </a:solidFill>
-                <a:latin typeface="Open Sans" pitchFamily="34" charset="0"/>
-                <a:ea typeface="Open Sans" pitchFamily="34" charset="-122"/>
-                <a:cs typeface="Open Sans" pitchFamily="34" charset="-120"/>
-              </a:rPr>
-              <a:t>   ·   05 / 09</a:t>
-            </a:r>
-            <a:endParaRPr lang="en-US" sz="1100" dirty="0"/>
-          </a:p>
-        </p:txBody>
-      </p:sp>
-      <p:sp>
-        <p:nvSpPr>
-          <p:cNvPr id="5" name="Text 2"/>
-          <p:cNvSpPr txBox="1"/>
-          <p:nvPr/>
-        </p:nvSpPr>
-        <p:spPr>
-          <a:xfrm>
-            <a:off x="640080" y="1097280"/>
+            <a:off x="640080" y="1280160"/>
             <a:ext cx="3429000" cy="1783080"/>
           </a:xfrm>
           <a:prstGeom prst="rect">
@@ -5171,13 +5111,13 @@
       </p:sp>
       <p:sp>
         <p:nvSpPr>
-          <p:cNvPr id="6" name="Text 3"/>
+          <p:cNvPr id="6" name="Text 2"/>
           <p:cNvSpPr txBox="1"/>
           <p:nvPr/>
         </p:nvSpPr>
         <p:spPr>
           <a:xfrm>
-            <a:off x="640080" y="2414016"/>
+            <a:off x="640080" y="2596896"/>
             <a:ext cx="3291840" cy="731520"/>
           </a:xfrm>
           <a:prstGeom prst="rect">
@@ -5210,13 +5150,13 @@
       </p:sp>
       <p:sp>
         <p:nvSpPr>
-          <p:cNvPr id="7" name="Shape 4"/>
+          <p:cNvPr id="7" name="Shape 3"/>
           <p:cNvSpPr/>
           <p:nvPr/>
         </p:nvSpPr>
         <p:spPr>
           <a:xfrm>
-            <a:off x="4389120" y="1143000"/>
+            <a:off x="4389120" y="1280160"/>
             <a:ext cx="7159752" cy="2651760"/>
           </a:xfrm>
           <a:prstGeom prst="roundRect">
@@ -5244,13 +5184,13 @@
       </p:sp>
       <p:sp>
         <p:nvSpPr>
-          <p:cNvPr id="8" name="Text 5"/>
+          <p:cNvPr id="8" name="Text 4"/>
           <p:cNvSpPr txBox="1"/>
           <p:nvPr/>
         </p:nvSpPr>
         <p:spPr>
           <a:xfrm>
-            <a:off x="4846320" y="1508760"/>
+            <a:off x="4846320" y="1645920"/>
             <a:ext cx="6245352" cy="320040"/>
           </a:xfrm>
           <a:prstGeom prst="rect">
@@ -5283,13 +5223,13 @@
       </p:sp>
       <p:sp>
         <p:nvSpPr>
-          <p:cNvPr id="9" name="Text 6"/>
+          <p:cNvPr id="9" name="Text 5"/>
           <p:cNvSpPr txBox="1"/>
           <p:nvPr/>
         </p:nvSpPr>
         <p:spPr>
           <a:xfrm>
-            <a:off x="4846320" y="1920240"/>
+            <a:off x="4846320" y="2057400"/>
             <a:ext cx="6245352" cy="1097280"/>
           </a:xfrm>
           <a:prstGeom prst="rect">
@@ -5336,13 +5276,13 @@
       </p:sp>
       <p:sp>
         <p:nvSpPr>
-          <p:cNvPr id="10" name="Text 7"/>
+          <p:cNvPr id="10" name="Text 6"/>
           <p:cNvSpPr txBox="1"/>
           <p:nvPr/>
         </p:nvSpPr>
         <p:spPr>
           <a:xfrm>
-            <a:off x="4846320" y="3063240"/>
+            <a:off x="4846320" y="3200400"/>
             <a:ext cx="6245352" cy="365760"/>
           </a:xfrm>
           <a:prstGeom prst="rect">
@@ -5375,13 +5315,13 @@
       </p:sp>
       <p:sp>
         <p:nvSpPr>
-          <p:cNvPr id="11" name="Shape 8"/>
+          <p:cNvPr id="11" name="Shape 7"/>
           <p:cNvSpPr/>
           <p:nvPr/>
         </p:nvSpPr>
         <p:spPr>
           <a:xfrm>
-            <a:off x="4389120" y="4069080"/>
+            <a:off x="4389120" y="4206240"/>
             <a:ext cx="7159752" cy="1417320"/>
           </a:xfrm>
           <a:prstGeom prst="roundRect">
@@ -5409,13 +5349,13 @@
       </p:sp>
       <p:sp>
         <p:nvSpPr>
-          <p:cNvPr id="12" name="Shape 9"/>
+          <p:cNvPr id="12" name="Shape 8"/>
           <p:cNvSpPr/>
           <p:nvPr/>
         </p:nvSpPr>
         <p:spPr>
           <a:xfrm>
-            <a:off x="4754880" y="4389120"/>
+            <a:off x="4754880" y="4526280"/>
             <a:ext cx="777240" cy="777240"/>
           </a:xfrm>
           <a:prstGeom prst="ellipse">
@@ -5434,21 +5374,21 @@
       </p:sp>
       <p:pic>
         <p:nvPicPr>
-          <p:cNvPr id="13" name="Image 0" descr="preencoded.png">    </p:cNvPr>
+          <p:cNvPr id="13" name="Image 1" descr="preencoded.png">    </p:cNvPr>
           <p:cNvPicPr>
             <a:picLocks noChangeAspect="1"/>
           </p:cNvPicPr>
           <p:nvPr/>
         </p:nvPicPr>
         <p:blipFill>
-          <a:blip r:embed="rId1"/>
+          <a:blip r:embed="rId2"/>
           <a:stretch>
             <a:fillRect/>
           </a:stretch>
         </p:blipFill>
         <p:spPr>
           <a:xfrm>
-            <a:off x="4964735" y="4598975"/>
+            <a:off x="4964735" y="4736135"/>
             <a:ext cx="357530" cy="357530"/>
           </a:xfrm>
           <a:prstGeom prst="rect">
@@ -5458,13 +5398,13 @@
       </p:pic>
       <p:sp>
         <p:nvSpPr>
-          <p:cNvPr id="14" name="Text 10"/>
+          <p:cNvPr id="14" name="Text 9"/>
           <p:cNvSpPr txBox="1"/>
           <p:nvPr/>
         </p:nvSpPr>
         <p:spPr>
           <a:xfrm>
-            <a:off x="5806440" y="4069080"/>
+            <a:off x="5806440" y="4206240"/>
             <a:ext cx="5422392" cy="1417320"/>
           </a:xfrm>
           <a:prstGeom prst="rect">
@@ -5520,13 +5460,13 @@
       </p:sp>
       <p:sp>
         <p:nvSpPr>
-          <p:cNvPr id="15" name="Text 11"/>
+          <p:cNvPr id="15" name="Text 10"/>
           <p:cNvSpPr txBox="1"/>
           <p:nvPr/>
         </p:nvSpPr>
         <p:spPr>
           <a:xfrm>
-            <a:off x="4389120" y="5669280"/>
+            <a:off x="4389120" y="5806440"/>
             <a:ext cx="7159752" cy="411480"/>
           </a:xfrm>
           <a:prstGeom prst="rect">
@@ -5589,16 +5529,40 @@
           <a:chExt cx="0" cy="0"/>
         </a:xfrm>
       </p:grpSpPr>
-      <p:sp>
-        <p:nvSpPr>
-          <p:cNvPr id="3" name="Text 0"/>
+      <p:pic>
+        <p:nvPicPr>
+          <p:cNvPr id="3" name="Image 0" descr="Breaking Barriers at work">    </p:cNvPr>
+          <p:cNvPicPr>
+            <a:picLocks noChangeAspect="1"/>
+          </p:cNvPicPr>
+          <p:nvPr/>
+        </p:nvPicPr>
+        <p:blipFill>
+          <a:blip r:embed="rId1"/>
+          <a:stretch>
+            <a:fillRect/>
+          </a:stretch>
+        </p:blipFill>
+        <p:spPr>
+          <a:xfrm>
+            <a:off x="640080" y="274320"/>
+            <a:ext cx="1188720" cy="542536"/>
+          </a:xfrm>
+          <a:prstGeom prst="rect">
+            <a:avLst/>
+          </a:prstGeom>
+        </p:spPr>
+      </p:pic>
+      <p:sp>
+        <p:nvSpPr>
+          <p:cNvPr id="4" name="Text 0"/>
           <p:cNvSpPr txBox="1"/>
           <p:nvPr/>
         </p:nvSpPr>
         <p:spPr>
           <a:xfrm>
-            <a:off x="640080" y="384048"/>
-            <a:ext cx="4572000" cy="274320"/>
+            <a:off x="7891272" y="384048"/>
+            <a:ext cx="3657600" cy="274320"/>
           </a:xfrm>
           <a:prstGeom prst="rect">
             <a:avLst/>
@@ -5610,86 +5574,47 @@
           <a:bodyPr wrap="square" lIns="0" tIns="0" rIns="0" bIns="0" rtlCol="0" anchor="ctr"/>
           <a:lstStyle/>
           <a:p>
-            <a:pPr indent="0" marL="0">
-              <a:buNone/>
-            </a:pPr>
-            <a:r>
-              <a:rPr lang="en-US" sz="1050" b="1" spc="300" kern="0" dirty="0">
-                <a:solidFill>
-                  <a:srgbClr val="C68C6C"/>
+            <a:pPr algn="r" indent="0" marL="0">
+              <a:buNone/>
+            </a:pPr>
+            <a:r>
+              <a:rPr lang="en-US" sz="1100" i="1" dirty="0">
+                <a:solidFill>
+                  <a:srgbClr val="8A6A55"/>
+                </a:solidFill>
+                <a:latin typeface="Source Serif Pro" pitchFamily="34" charset="0"/>
+                <a:ea typeface="Source Serif Pro" pitchFamily="34" charset="-122"/>
+                <a:cs typeface="Source Serif Pro" pitchFamily="34" charset="-120"/>
+              </a:rPr>
+              <a:t>by Flor Pérsico</a:t>
+            </a:r>
+            <a:pPr algn="r" indent="0" marL="0">
+              <a:buNone/>
+            </a:pPr>
+            <a:r>
+              <a:rPr lang="en-US" sz="1100" dirty="0">
+                <a:solidFill>
+                  <a:srgbClr val="8A6A55"/>
                 </a:solidFill>
                 <a:latin typeface="Open Sans" pitchFamily="34" charset="0"/>
                 <a:ea typeface="Open Sans" pitchFamily="34" charset="-122"/>
                 <a:cs typeface="Open Sans" pitchFamily="34" charset="-120"/>
               </a:rPr>
-              <a:t>BREAKING BARRIERS · AT WORK</a:t>
-            </a:r>
-            <a:endParaRPr lang="en-US" sz="1050" dirty="0"/>
-          </a:p>
-        </p:txBody>
-      </p:sp>
-      <p:sp>
-        <p:nvSpPr>
-          <p:cNvPr id="4" name="Text 1"/>
+              <a:t>   ·   06 / 09</a:t>
+            </a:r>
+            <a:endParaRPr lang="en-US" sz="1100" dirty="0"/>
+          </a:p>
+        </p:txBody>
+      </p:sp>
+      <p:sp>
+        <p:nvSpPr>
+          <p:cNvPr id="5" name="Text 1"/>
           <p:cNvSpPr txBox="1"/>
           <p:nvPr/>
         </p:nvSpPr>
         <p:spPr>
           <a:xfrm>
-            <a:off x="7891272" y="384048"/>
-            <a:ext cx="3657600" cy="274320"/>
-          </a:xfrm>
-          <a:prstGeom prst="rect">
-            <a:avLst/>
-          </a:prstGeom>
-          <a:noFill/>
-          <a:ln/>
-        </p:spPr>
-        <p:txBody>
-          <a:bodyPr wrap="square" lIns="0" tIns="0" rIns="0" bIns="0" rtlCol="0" anchor="ctr"/>
-          <a:lstStyle/>
-          <a:p>
-            <a:pPr algn="r" indent="0" marL="0">
-              <a:buNone/>
-            </a:pPr>
-            <a:r>
-              <a:rPr lang="en-US" sz="1100" i="1" dirty="0">
-                <a:solidFill>
-                  <a:srgbClr val="8A6A55"/>
-                </a:solidFill>
-                <a:latin typeface="Source Serif Pro" pitchFamily="34" charset="0"/>
-                <a:ea typeface="Source Serif Pro" pitchFamily="34" charset="-122"/>
-                <a:cs typeface="Source Serif Pro" pitchFamily="34" charset="-120"/>
-              </a:rPr>
-              <a:t>by Flor Pérsico</a:t>
-            </a:r>
-            <a:pPr algn="r" indent="0" marL="0">
-              <a:buNone/>
-            </a:pPr>
-            <a:r>
-              <a:rPr lang="en-US" sz="1100" dirty="0">
-                <a:solidFill>
-                  <a:srgbClr val="8A6A55"/>
-                </a:solidFill>
-                <a:latin typeface="Open Sans" pitchFamily="34" charset="0"/>
-                <a:ea typeface="Open Sans" pitchFamily="34" charset="-122"/>
-                <a:cs typeface="Open Sans" pitchFamily="34" charset="-120"/>
-              </a:rPr>
-              <a:t>   ·   06 / 09</a:t>
-            </a:r>
-            <a:endParaRPr lang="en-US" sz="1100" dirty="0"/>
-          </a:p>
-        </p:txBody>
-      </p:sp>
-      <p:sp>
-        <p:nvSpPr>
-          <p:cNvPr id="5" name="Text 2"/>
-          <p:cNvSpPr txBox="1"/>
-          <p:nvPr/>
-        </p:nvSpPr>
-        <p:spPr>
-          <a:xfrm>
-            <a:off x="640080" y="1097280"/>
+            <a:off x="640080" y="1280160"/>
             <a:ext cx="3429000" cy="1783080"/>
           </a:xfrm>
           <a:prstGeom prst="rect">
@@ -5725,13 +5650,13 @@
       </p:sp>
       <p:sp>
         <p:nvSpPr>
-          <p:cNvPr id="6" name="Text 3"/>
+          <p:cNvPr id="6" name="Text 2"/>
           <p:cNvSpPr txBox="1"/>
           <p:nvPr/>
         </p:nvSpPr>
         <p:spPr>
           <a:xfrm>
-            <a:off x="640080" y="2414016"/>
+            <a:off x="640080" y="2596896"/>
             <a:ext cx="3291840" cy="731520"/>
           </a:xfrm>
           <a:prstGeom prst="rect">
@@ -5764,13 +5689,13 @@
       </p:sp>
       <p:sp>
         <p:nvSpPr>
-          <p:cNvPr id="7" name="Shape 4"/>
+          <p:cNvPr id="7" name="Shape 3"/>
           <p:cNvSpPr/>
           <p:nvPr/>
         </p:nvSpPr>
         <p:spPr>
           <a:xfrm>
-            <a:off x="4389120" y="1143000"/>
+            <a:off x="4389120" y="1280160"/>
             <a:ext cx="1618488" cy="2606040"/>
           </a:xfrm>
           <a:prstGeom prst="roundRect">
@@ -5798,13 +5723,13 @@
       </p:sp>
       <p:sp>
         <p:nvSpPr>
-          <p:cNvPr id="8" name="Shape 5"/>
+          <p:cNvPr id="8" name="Shape 4"/>
           <p:cNvSpPr/>
           <p:nvPr/>
         </p:nvSpPr>
         <p:spPr>
           <a:xfrm>
-            <a:off x="4786884" y="1463040"/>
+            <a:off x="4786884" y="1600200"/>
             <a:ext cx="822960" cy="822960"/>
           </a:xfrm>
           <a:prstGeom prst="ellipse">
@@ -5823,21 +5748,21 @@
       </p:sp>
       <p:pic>
         <p:nvPicPr>
-          <p:cNvPr id="9" name="Image 0" descr="preencoded.png">    </p:cNvPr>
+          <p:cNvPr id="9" name="Image 1" descr="preencoded.png">    </p:cNvPr>
           <p:cNvPicPr>
             <a:picLocks noChangeAspect="1"/>
           </p:cNvPicPr>
           <p:nvPr/>
         </p:nvPicPr>
         <p:blipFill>
-          <a:blip r:embed="rId1"/>
+          <a:blip r:embed="rId2"/>
           <a:stretch>
             <a:fillRect/>
           </a:stretch>
         </p:blipFill>
         <p:spPr>
           <a:xfrm>
-            <a:off x="5009083" y="1685239"/>
+            <a:off x="5009083" y="1822399"/>
             <a:ext cx="378562" cy="378562"/>
           </a:xfrm>
           <a:prstGeom prst="rect">
@@ -5847,13 +5772,13 @@
       </p:pic>
       <p:sp>
         <p:nvSpPr>
-          <p:cNvPr id="10" name="Text 6"/>
+          <p:cNvPr id="10" name="Text 5"/>
           <p:cNvSpPr txBox="1"/>
           <p:nvPr/>
         </p:nvSpPr>
         <p:spPr>
           <a:xfrm>
-            <a:off x="4526280" y="2423160"/>
+            <a:off x="4526280" y="2560320"/>
             <a:ext cx="1344168" cy="1143000"/>
           </a:xfrm>
           <a:prstGeom prst="rect">
@@ -5886,13 +5811,13 @@
       </p:sp>
       <p:sp>
         <p:nvSpPr>
-          <p:cNvPr id="11" name="Shape 7"/>
+          <p:cNvPr id="11" name="Shape 6"/>
           <p:cNvSpPr/>
           <p:nvPr/>
         </p:nvSpPr>
         <p:spPr>
           <a:xfrm>
-            <a:off x="6236208" y="1143000"/>
+            <a:off x="6236208" y="1280160"/>
             <a:ext cx="1618488" cy="2606040"/>
           </a:xfrm>
           <a:prstGeom prst="roundRect">
@@ -5920,13 +5845,13 @@
       </p:sp>
       <p:sp>
         <p:nvSpPr>
-          <p:cNvPr id="12" name="Shape 8"/>
+          <p:cNvPr id="12" name="Shape 7"/>
           <p:cNvSpPr/>
           <p:nvPr/>
         </p:nvSpPr>
         <p:spPr>
           <a:xfrm>
-            <a:off x="6633972" y="1463040"/>
+            <a:off x="6633972" y="1600200"/>
             <a:ext cx="822960" cy="822960"/>
           </a:xfrm>
           <a:prstGeom prst="ellipse">
@@ -5945,21 +5870,21 @@
       </p:sp>
       <p:pic>
         <p:nvPicPr>
-          <p:cNvPr id="13" name="Image 1" descr="preencoded.png">    </p:cNvPr>
+          <p:cNvPr id="13" name="Image 2" descr="preencoded.png">    </p:cNvPr>
           <p:cNvPicPr>
             <a:picLocks noChangeAspect="1"/>
           </p:cNvPicPr>
           <p:nvPr/>
         </p:nvPicPr>
         <p:blipFill>
-          <a:blip r:embed="rId2"/>
+          <a:blip r:embed="rId3"/>
           <a:stretch>
             <a:fillRect/>
           </a:stretch>
         </p:blipFill>
         <p:spPr>
           <a:xfrm>
-            <a:off x="6856171" y="1685239"/>
+            <a:off x="6856171" y="1822399"/>
             <a:ext cx="378562" cy="378562"/>
           </a:xfrm>
           <a:prstGeom prst="rect">
@@ -5969,13 +5894,13 @@
       </p:pic>
       <p:sp>
         <p:nvSpPr>
-          <p:cNvPr id="14" name="Text 9"/>
+          <p:cNvPr id="14" name="Text 8"/>
           <p:cNvSpPr txBox="1"/>
           <p:nvPr/>
         </p:nvSpPr>
         <p:spPr>
           <a:xfrm>
-            <a:off x="6373368" y="2423160"/>
+            <a:off x="6373368" y="2560320"/>
             <a:ext cx="1344168" cy="1143000"/>
           </a:xfrm>
           <a:prstGeom prst="rect">
@@ -6008,13 +5933,13 @@
       </p:sp>
       <p:sp>
         <p:nvSpPr>
-          <p:cNvPr id="15" name="Shape 10"/>
+          <p:cNvPr id="15" name="Shape 9"/>
           <p:cNvSpPr/>
           <p:nvPr/>
         </p:nvSpPr>
         <p:spPr>
           <a:xfrm>
-            <a:off x="8083296" y="1143000"/>
+            <a:off x="8083296" y="1280160"/>
             <a:ext cx="1618488" cy="2606040"/>
           </a:xfrm>
           <a:prstGeom prst="roundRect">
@@ -6042,13 +5967,13 @@
       </p:sp>
       <p:sp>
         <p:nvSpPr>
-          <p:cNvPr id="16" name="Shape 11"/>
+          <p:cNvPr id="16" name="Shape 10"/>
           <p:cNvSpPr/>
           <p:nvPr/>
         </p:nvSpPr>
         <p:spPr>
           <a:xfrm>
-            <a:off x="8481060" y="1463040"/>
+            <a:off x="8481060" y="1600200"/>
             <a:ext cx="822960" cy="822960"/>
           </a:xfrm>
           <a:prstGeom prst="ellipse">
@@ -6067,21 +5992,21 @@
       </p:sp>
       <p:pic>
         <p:nvPicPr>
-          <p:cNvPr id="17" name="Image 2" descr="preencoded.png">    </p:cNvPr>
+          <p:cNvPr id="17" name="Image 3" descr="preencoded.png">    </p:cNvPr>
           <p:cNvPicPr>
             <a:picLocks noChangeAspect="1"/>
           </p:cNvPicPr>
           <p:nvPr/>
         </p:nvPicPr>
         <p:blipFill>
-          <a:blip r:embed="rId3"/>
+          <a:blip r:embed="rId4"/>
           <a:stretch>
             <a:fillRect/>
           </a:stretch>
         </p:blipFill>
         <p:spPr>
           <a:xfrm>
-            <a:off x="8703259" y="1685239"/>
+            <a:off x="8703259" y="1822399"/>
             <a:ext cx="378562" cy="378562"/>
           </a:xfrm>
           <a:prstGeom prst="rect">
@@ -6091,13 +6016,13 @@
       </p:pic>
       <p:sp>
         <p:nvSpPr>
-          <p:cNvPr id="18" name="Text 12"/>
+          <p:cNvPr id="18" name="Text 11"/>
           <p:cNvSpPr txBox="1"/>
           <p:nvPr/>
         </p:nvSpPr>
         <p:spPr>
           <a:xfrm>
-            <a:off x="8220456" y="2423160"/>
+            <a:off x="8220456" y="2560320"/>
             <a:ext cx="1344168" cy="1143000"/>
           </a:xfrm>
           <a:prstGeom prst="rect">
@@ -6130,13 +6055,13 @@
       </p:sp>
       <p:sp>
         <p:nvSpPr>
-          <p:cNvPr id="19" name="Shape 13"/>
+          <p:cNvPr id="19" name="Shape 12"/>
           <p:cNvSpPr/>
           <p:nvPr/>
         </p:nvSpPr>
         <p:spPr>
           <a:xfrm>
-            <a:off x="9930384" y="1143000"/>
+            <a:off x="9930384" y="1280160"/>
             <a:ext cx="1618488" cy="2606040"/>
           </a:xfrm>
           <a:prstGeom prst="roundRect">
@@ -6164,13 +6089,13 @@
       </p:sp>
       <p:sp>
         <p:nvSpPr>
-          <p:cNvPr id="20" name="Shape 14"/>
+          <p:cNvPr id="20" name="Shape 13"/>
           <p:cNvSpPr/>
           <p:nvPr/>
         </p:nvSpPr>
         <p:spPr>
           <a:xfrm>
-            <a:off x="10328148" y="1463040"/>
+            <a:off x="10328148" y="1600200"/>
             <a:ext cx="822960" cy="822960"/>
           </a:xfrm>
           <a:prstGeom prst="ellipse">
@@ -6189,21 +6114,21 @@
       </p:sp>
       <p:pic>
         <p:nvPicPr>
-          <p:cNvPr id="21" name="Image 3" descr="preencoded.png">    </p:cNvPr>
+          <p:cNvPr id="21" name="Image 4" descr="preencoded.png">    </p:cNvPr>
           <p:cNvPicPr>
             <a:picLocks noChangeAspect="1"/>
           </p:cNvPicPr>
           <p:nvPr/>
         </p:nvPicPr>
         <p:blipFill>
-          <a:blip r:embed="rId4"/>
+          <a:blip r:embed="rId5"/>
           <a:stretch>
             <a:fillRect/>
           </a:stretch>
         </p:blipFill>
         <p:spPr>
           <a:xfrm>
-            <a:off x="10550347" y="1685239"/>
+            <a:off x="10550347" y="1822399"/>
             <a:ext cx="378562" cy="378562"/>
           </a:xfrm>
           <a:prstGeom prst="rect">
@@ -6213,13 +6138,13 @@
       </p:pic>
       <p:sp>
         <p:nvSpPr>
-          <p:cNvPr id="22" name="Text 15"/>
+          <p:cNvPr id="22" name="Text 14"/>
           <p:cNvSpPr txBox="1"/>
           <p:nvPr/>
         </p:nvSpPr>
         <p:spPr>
           <a:xfrm>
-            <a:off x="10067544" y="2423160"/>
+            <a:off x="10067544" y="2560320"/>
             <a:ext cx="1344168" cy="1143000"/>
           </a:xfrm>
           <a:prstGeom prst="rect">
@@ -6252,13 +6177,13 @@
       </p:sp>
       <p:sp>
         <p:nvSpPr>
-          <p:cNvPr id="23" name="Shape 16"/>
+          <p:cNvPr id="23" name="Shape 15"/>
           <p:cNvSpPr/>
           <p:nvPr/>
         </p:nvSpPr>
         <p:spPr>
           <a:xfrm>
-            <a:off x="4389120" y="4069080"/>
+            <a:off x="4389120" y="4206240"/>
             <a:ext cx="7159752" cy="1965960"/>
           </a:xfrm>
           <a:prstGeom prst="roundRect">
@@ -6286,13 +6211,13 @@
       </p:sp>
       <p:sp>
         <p:nvSpPr>
-          <p:cNvPr id="24" name="Shape 17"/>
+          <p:cNvPr id="24" name="Shape 16"/>
           <p:cNvSpPr/>
           <p:nvPr/>
         </p:nvSpPr>
         <p:spPr>
           <a:xfrm>
-            <a:off x="4754880" y="4663440"/>
+            <a:off x="4754880" y="4800600"/>
             <a:ext cx="777240" cy="777240"/>
           </a:xfrm>
           <a:prstGeom prst="ellipse">
@@ -6311,21 +6236,21 @@
       </p:sp>
       <p:pic>
         <p:nvPicPr>
-          <p:cNvPr id="25" name="Image 4" descr="preencoded.png">    </p:cNvPr>
+          <p:cNvPr id="25" name="Image 5" descr="preencoded.png">    </p:cNvPr>
           <p:cNvPicPr>
             <a:picLocks noChangeAspect="1"/>
           </p:cNvPicPr>
           <p:nvPr/>
         </p:nvPicPr>
         <p:blipFill>
-          <a:blip r:embed="rId5"/>
+          <a:blip r:embed="rId6"/>
           <a:stretch>
             <a:fillRect/>
           </a:stretch>
         </p:blipFill>
         <p:spPr>
           <a:xfrm>
-            <a:off x="4964735" y="4873295"/>
+            <a:off x="4964735" y="5010455"/>
             <a:ext cx="357530" cy="357530"/>
           </a:xfrm>
           <a:prstGeom prst="rect">
@@ -6335,13 +6260,13 @@
       </p:pic>
       <p:sp>
         <p:nvSpPr>
-          <p:cNvPr id="26" name="Text 18"/>
+          <p:cNvPr id="26" name="Text 17"/>
           <p:cNvSpPr txBox="1"/>
           <p:nvPr/>
         </p:nvSpPr>
         <p:spPr>
           <a:xfrm>
-            <a:off x="5806440" y="4069080"/>
+            <a:off x="5806440" y="4206240"/>
             <a:ext cx="5422392" cy="1965960"/>
           </a:xfrm>
           <a:prstGeom prst="rect">
@@ -6427,16 +6352,40 @@
           <a:chExt cx="0" cy="0"/>
         </a:xfrm>
       </p:grpSpPr>
-      <p:sp>
-        <p:nvSpPr>
-          <p:cNvPr id="3" name="Text 0"/>
+      <p:pic>
+        <p:nvPicPr>
+          <p:cNvPr id="3" name="Image 0" descr="Breaking Barriers at work">    </p:cNvPr>
+          <p:cNvPicPr>
+            <a:picLocks noChangeAspect="1"/>
+          </p:cNvPicPr>
+          <p:nvPr/>
+        </p:nvPicPr>
+        <p:blipFill>
+          <a:blip r:embed="rId1"/>
+          <a:stretch>
+            <a:fillRect/>
+          </a:stretch>
+        </p:blipFill>
+        <p:spPr>
+          <a:xfrm>
+            <a:off x="640080" y="274320"/>
+            <a:ext cx="1188720" cy="542536"/>
+          </a:xfrm>
+          <a:prstGeom prst="rect">
+            <a:avLst/>
+          </a:prstGeom>
+        </p:spPr>
+      </p:pic>
+      <p:sp>
+        <p:nvSpPr>
+          <p:cNvPr id="4" name="Text 0"/>
           <p:cNvSpPr txBox="1"/>
           <p:nvPr/>
         </p:nvSpPr>
         <p:spPr>
           <a:xfrm>
-            <a:off x="640080" y="384048"/>
-            <a:ext cx="4572000" cy="274320"/>
+            <a:off x="7891272" y="384048"/>
+            <a:ext cx="3657600" cy="274320"/>
           </a:xfrm>
           <a:prstGeom prst="rect">
             <a:avLst/>
@@ -6448,86 +6397,47 @@
           <a:bodyPr wrap="square" lIns="0" tIns="0" rIns="0" bIns="0" rtlCol="0" anchor="ctr"/>
           <a:lstStyle/>
           <a:p>
-            <a:pPr indent="0" marL="0">
-              <a:buNone/>
-            </a:pPr>
-            <a:r>
-              <a:rPr lang="en-US" sz="1050" b="1" spc="300" kern="0" dirty="0">
-                <a:solidFill>
-                  <a:srgbClr val="C68C6C"/>
+            <a:pPr algn="r" indent="0" marL="0">
+              <a:buNone/>
+            </a:pPr>
+            <a:r>
+              <a:rPr lang="en-US" sz="1100" i="1" dirty="0">
+                <a:solidFill>
+                  <a:srgbClr val="8A6A55"/>
+                </a:solidFill>
+                <a:latin typeface="Source Serif Pro" pitchFamily="34" charset="0"/>
+                <a:ea typeface="Source Serif Pro" pitchFamily="34" charset="-122"/>
+                <a:cs typeface="Source Serif Pro" pitchFamily="34" charset="-120"/>
+              </a:rPr>
+              <a:t>by Flor Pérsico</a:t>
+            </a:r>
+            <a:pPr algn="r" indent="0" marL="0">
+              <a:buNone/>
+            </a:pPr>
+            <a:r>
+              <a:rPr lang="en-US" sz="1100" dirty="0">
+                <a:solidFill>
+                  <a:srgbClr val="8A6A55"/>
                 </a:solidFill>
                 <a:latin typeface="Open Sans" pitchFamily="34" charset="0"/>
                 <a:ea typeface="Open Sans" pitchFamily="34" charset="-122"/>
                 <a:cs typeface="Open Sans" pitchFamily="34" charset="-120"/>
               </a:rPr>
-              <a:t>BREAKING BARRIERS · AT WORK</a:t>
-            </a:r>
-            <a:endParaRPr lang="en-US" sz="1050" dirty="0"/>
-          </a:p>
-        </p:txBody>
-      </p:sp>
-      <p:sp>
-        <p:nvSpPr>
-          <p:cNvPr id="4" name="Text 1"/>
+              <a:t>   ·   07 / 09</a:t>
+            </a:r>
+            <a:endParaRPr lang="en-US" sz="1100" dirty="0"/>
+          </a:p>
+        </p:txBody>
+      </p:sp>
+      <p:sp>
+        <p:nvSpPr>
+          <p:cNvPr id="5" name="Text 1"/>
           <p:cNvSpPr txBox="1"/>
           <p:nvPr/>
         </p:nvSpPr>
         <p:spPr>
           <a:xfrm>
-            <a:off x="7891272" y="384048"/>
-            <a:ext cx="3657600" cy="274320"/>
-          </a:xfrm>
-          <a:prstGeom prst="rect">
-            <a:avLst/>
-          </a:prstGeom>
-          <a:noFill/>
-          <a:ln/>
-        </p:spPr>
-        <p:txBody>
-          <a:bodyPr wrap="square" lIns="0" tIns="0" rIns="0" bIns="0" rtlCol="0" anchor="ctr"/>
-          <a:lstStyle/>
-          <a:p>
-            <a:pPr algn="r" indent="0" marL="0">
-              <a:buNone/>
-            </a:pPr>
-            <a:r>
-              <a:rPr lang="en-US" sz="1100" i="1" dirty="0">
-                <a:solidFill>
-                  <a:srgbClr val="8A6A55"/>
-                </a:solidFill>
-                <a:latin typeface="Source Serif Pro" pitchFamily="34" charset="0"/>
-                <a:ea typeface="Source Serif Pro" pitchFamily="34" charset="-122"/>
-                <a:cs typeface="Source Serif Pro" pitchFamily="34" charset="-120"/>
-              </a:rPr>
-              <a:t>by Flor Pérsico</a:t>
-            </a:r>
-            <a:pPr algn="r" indent="0" marL="0">
-              <a:buNone/>
-            </a:pPr>
-            <a:r>
-              <a:rPr lang="en-US" sz="1100" dirty="0">
-                <a:solidFill>
-                  <a:srgbClr val="8A6A55"/>
-                </a:solidFill>
-                <a:latin typeface="Open Sans" pitchFamily="34" charset="0"/>
-                <a:ea typeface="Open Sans" pitchFamily="34" charset="-122"/>
-                <a:cs typeface="Open Sans" pitchFamily="34" charset="-120"/>
-              </a:rPr>
-              <a:t>   ·   07 / 09</a:t>
-            </a:r>
-            <a:endParaRPr lang="en-US" sz="1100" dirty="0"/>
-          </a:p>
-        </p:txBody>
-      </p:sp>
-      <p:sp>
-        <p:nvSpPr>
-          <p:cNvPr id="5" name="Text 2"/>
-          <p:cNvSpPr txBox="1"/>
-          <p:nvPr/>
-        </p:nvSpPr>
-        <p:spPr>
-          <a:xfrm>
-            <a:off x="640080" y="1097280"/>
+            <a:off x="640080" y="1280160"/>
             <a:ext cx="3429000" cy="1783080"/>
           </a:xfrm>
           <a:prstGeom prst="rect">
@@ -6563,13 +6473,13 @@
       </p:sp>
       <p:sp>
         <p:nvSpPr>
-          <p:cNvPr id="6" name="Text 3"/>
+          <p:cNvPr id="6" name="Text 2"/>
           <p:cNvSpPr txBox="1"/>
           <p:nvPr/>
         </p:nvSpPr>
         <p:spPr>
           <a:xfrm>
-            <a:off x="640080" y="2414016"/>
+            <a:off x="640080" y="2596896"/>
             <a:ext cx="3291840" cy="731520"/>
           </a:xfrm>
           <a:prstGeom prst="rect">
@@ -6602,13 +6512,13 @@
       </p:sp>
       <p:sp>
         <p:nvSpPr>
-          <p:cNvPr id="7" name="Text 4"/>
+          <p:cNvPr id="7" name="Text 3"/>
           <p:cNvSpPr txBox="1"/>
           <p:nvPr/>
         </p:nvSpPr>
         <p:spPr>
           <a:xfrm>
-            <a:off x="4389120" y="1143000"/>
+            <a:off x="4389120" y="1280160"/>
             <a:ext cx="7159752" cy="320040"/>
           </a:xfrm>
           <a:prstGeom prst="rect">
@@ -6641,13 +6551,13 @@
       </p:sp>
       <p:sp>
         <p:nvSpPr>
-          <p:cNvPr id="8" name="Shape 5"/>
+          <p:cNvPr id="8" name="Shape 4"/>
           <p:cNvSpPr/>
           <p:nvPr/>
         </p:nvSpPr>
         <p:spPr>
           <a:xfrm>
-            <a:off x="4389120" y="1600200"/>
+            <a:off x="4389120" y="1737360"/>
             <a:ext cx="3465576" cy="777240"/>
           </a:xfrm>
           <a:prstGeom prst="roundRect">
@@ -6675,13 +6585,13 @@
       </p:sp>
       <p:sp>
         <p:nvSpPr>
-          <p:cNvPr id="9" name="Shape 6"/>
+          <p:cNvPr id="9" name="Shape 5"/>
           <p:cNvSpPr/>
           <p:nvPr/>
         </p:nvSpPr>
         <p:spPr>
           <a:xfrm>
-            <a:off x="4590288" y="1723644"/>
+            <a:off x="4590288" y="1860804"/>
             <a:ext cx="530352" cy="530352"/>
           </a:xfrm>
           <a:prstGeom prst="ellipse">
@@ -6700,21 +6610,21 @@
       </p:sp>
       <p:pic>
         <p:nvPicPr>
-          <p:cNvPr id="10" name="Image 0" descr="preencoded.png">    </p:cNvPr>
+          <p:cNvPr id="10" name="Image 1" descr="preencoded.png">    </p:cNvPr>
           <p:cNvPicPr>
             <a:picLocks noChangeAspect="1"/>
           </p:cNvPicPr>
           <p:nvPr/>
         </p:nvPicPr>
         <p:blipFill>
-          <a:blip r:embed="rId1"/>
+          <a:blip r:embed="rId2"/>
           <a:stretch>
             <a:fillRect/>
           </a:stretch>
         </p:blipFill>
         <p:spPr>
           <a:xfrm>
-            <a:off x="4733483" y="1866839"/>
+            <a:off x="4733483" y="2003999"/>
             <a:ext cx="243962" cy="243962"/>
           </a:xfrm>
           <a:prstGeom prst="rect">
@@ -6724,13 +6634,13 @@
       </p:pic>
       <p:sp>
         <p:nvSpPr>
-          <p:cNvPr id="11" name="Text 7"/>
+          <p:cNvPr id="11" name="Text 6"/>
           <p:cNvSpPr txBox="1"/>
           <p:nvPr/>
         </p:nvSpPr>
         <p:spPr>
           <a:xfrm>
-            <a:off x="5285232" y="1600200"/>
+            <a:off x="5285232" y="1737360"/>
             <a:ext cx="2414016" cy="777240"/>
           </a:xfrm>
           <a:prstGeom prst="rect">
@@ -6763,13 +6673,13 @@
       </p:sp>
       <p:sp>
         <p:nvSpPr>
-          <p:cNvPr id="12" name="Shape 8"/>
+          <p:cNvPr id="12" name="Shape 7"/>
           <p:cNvSpPr/>
           <p:nvPr/>
         </p:nvSpPr>
         <p:spPr>
           <a:xfrm>
-            <a:off x="8083296" y="1600200"/>
+            <a:off x="8083296" y="1737360"/>
             <a:ext cx="3465576" cy="777240"/>
           </a:xfrm>
           <a:prstGeom prst="roundRect">
@@ -6797,13 +6707,13 @@
       </p:sp>
       <p:sp>
         <p:nvSpPr>
-          <p:cNvPr id="13" name="Shape 9"/>
+          <p:cNvPr id="13" name="Shape 8"/>
           <p:cNvSpPr/>
           <p:nvPr/>
         </p:nvSpPr>
         <p:spPr>
           <a:xfrm>
-            <a:off x="8284464" y="1723644"/>
+            <a:off x="8284464" y="1860804"/>
             <a:ext cx="530352" cy="530352"/>
           </a:xfrm>
           <a:prstGeom prst="ellipse">
@@ -6822,21 +6732,21 @@
       </p:sp>
       <p:pic>
         <p:nvPicPr>
-          <p:cNvPr id="14" name="Image 1" descr="preencoded.png">    </p:cNvPr>
+          <p:cNvPr id="14" name="Image 2" descr="preencoded.png">    </p:cNvPr>
           <p:cNvPicPr>
             <a:picLocks noChangeAspect="1"/>
           </p:cNvPicPr>
           <p:nvPr/>
         </p:nvPicPr>
         <p:blipFill>
-          <a:blip r:embed="rId2"/>
+          <a:blip r:embed="rId3"/>
           <a:stretch>
             <a:fillRect/>
           </a:stretch>
         </p:blipFill>
         <p:spPr>
           <a:xfrm>
-            <a:off x="8427659" y="1866839"/>
+            <a:off x="8427659" y="2003999"/>
             <a:ext cx="243962" cy="243962"/>
           </a:xfrm>
           <a:prstGeom prst="rect">
@@ -6846,13 +6756,13 @@
       </p:pic>
       <p:sp>
         <p:nvSpPr>
-          <p:cNvPr id="15" name="Text 10"/>
+          <p:cNvPr id="15" name="Text 9"/>
           <p:cNvSpPr txBox="1"/>
           <p:nvPr/>
         </p:nvSpPr>
         <p:spPr>
           <a:xfrm>
-            <a:off x="8979408" y="1600200"/>
+            <a:off x="8979408" y="1737360"/>
             <a:ext cx="2414016" cy="777240"/>
           </a:xfrm>
           <a:prstGeom prst="rect">
@@ -6885,13 +6795,13 @@
       </p:sp>
       <p:sp>
         <p:nvSpPr>
-          <p:cNvPr id="16" name="Shape 11"/>
+          <p:cNvPr id="16" name="Shape 10"/>
           <p:cNvSpPr/>
           <p:nvPr/>
         </p:nvSpPr>
         <p:spPr>
           <a:xfrm>
-            <a:off x="4389120" y="2560320"/>
+            <a:off x="4389120" y="2697480"/>
             <a:ext cx="3465576" cy="777240"/>
           </a:xfrm>
           <a:prstGeom prst="roundRect">
@@ -6919,13 +6829,13 @@
       </p:sp>
       <p:sp>
         <p:nvSpPr>
-          <p:cNvPr id="17" name="Shape 12"/>
+          <p:cNvPr id="17" name="Shape 11"/>
           <p:cNvSpPr/>
           <p:nvPr/>
         </p:nvSpPr>
         <p:spPr>
           <a:xfrm>
-            <a:off x="4590288" y="2683764"/>
+            <a:off x="4590288" y="2820924"/>
             <a:ext cx="530352" cy="530352"/>
           </a:xfrm>
           <a:prstGeom prst="ellipse">
@@ -6944,21 +6854,21 @@
       </p:sp>
       <p:pic>
         <p:nvPicPr>
-          <p:cNvPr id="18" name="Image 2" descr="preencoded.png">    </p:cNvPr>
+          <p:cNvPr id="18" name="Image 3" descr="preencoded.png">    </p:cNvPr>
           <p:cNvPicPr>
             <a:picLocks noChangeAspect="1"/>
           </p:cNvPicPr>
           <p:nvPr/>
         </p:nvPicPr>
         <p:blipFill>
-          <a:blip r:embed="rId3"/>
+          <a:blip r:embed="rId4"/>
           <a:stretch>
             <a:fillRect/>
           </a:stretch>
         </p:blipFill>
         <p:spPr>
           <a:xfrm>
-            <a:off x="4733483" y="2826959"/>
+            <a:off x="4733483" y="2964119"/>
             <a:ext cx="243962" cy="243962"/>
           </a:xfrm>
           <a:prstGeom prst="rect">
@@ -6968,13 +6878,13 @@
       </p:pic>
       <p:sp>
         <p:nvSpPr>
-          <p:cNvPr id="19" name="Text 13"/>
+          <p:cNvPr id="19" name="Text 12"/>
           <p:cNvSpPr txBox="1"/>
           <p:nvPr/>
         </p:nvSpPr>
         <p:spPr>
           <a:xfrm>
-            <a:off x="5285232" y="2560320"/>
+            <a:off x="5285232" y="2697480"/>
             <a:ext cx="2414016" cy="777240"/>
           </a:xfrm>
           <a:prstGeom prst="rect">
@@ -7007,13 +6917,13 @@
       </p:sp>
       <p:sp>
         <p:nvSpPr>
-          <p:cNvPr id="20" name="Shape 14"/>
+          <p:cNvPr id="20" name="Shape 13"/>
           <p:cNvSpPr/>
           <p:nvPr/>
         </p:nvSpPr>
         <p:spPr>
           <a:xfrm>
-            <a:off x="8083296" y="2560320"/>
+            <a:off x="8083296" y="2697480"/>
             <a:ext cx="3465576" cy="777240"/>
           </a:xfrm>
           <a:prstGeom prst="roundRect">
@@ -7041,13 +6951,13 @@
       </p:sp>
       <p:sp>
         <p:nvSpPr>
-          <p:cNvPr id="21" name="Shape 15"/>
+          <p:cNvPr id="21" name="Shape 14"/>
           <p:cNvSpPr/>
           <p:nvPr/>
         </p:nvSpPr>
         <p:spPr>
           <a:xfrm>
-            <a:off x="8284464" y="2683764"/>
+            <a:off x="8284464" y="2820924"/>
             <a:ext cx="530352" cy="530352"/>
           </a:xfrm>
           <a:prstGeom prst="ellipse">
@@ -7066,21 +6976,21 @@
       </p:sp>
       <p:pic>
         <p:nvPicPr>
-          <p:cNvPr id="22" name="Image 3" descr="preencoded.png">    </p:cNvPr>
+          <p:cNvPr id="22" name="Image 4" descr="preencoded.png">    </p:cNvPr>
           <p:cNvPicPr>
             <a:picLocks noChangeAspect="1"/>
           </p:cNvPicPr>
           <p:nvPr/>
         </p:nvPicPr>
         <p:blipFill>
-          <a:blip r:embed="rId4"/>
+          <a:blip r:embed="rId5"/>
           <a:stretch>
             <a:fillRect/>
           </a:stretch>
         </p:blipFill>
         <p:spPr>
           <a:xfrm>
-            <a:off x="8427659" y="2826959"/>
+            <a:off x="8427659" y="2964119"/>
             <a:ext cx="243962" cy="243962"/>
           </a:xfrm>
           <a:prstGeom prst="rect">
@@ -7090,13 +7000,13 @@
       </p:pic>
       <p:sp>
         <p:nvSpPr>
-          <p:cNvPr id="23" name="Text 16"/>
+          <p:cNvPr id="23" name="Text 15"/>
           <p:cNvSpPr txBox="1"/>
           <p:nvPr/>
         </p:nvSpPr>
         <p:spPr>
           <a:xfrm>
-            <a:off x="8979408" y="2560320"/>
+            <a:off x="8979408" y="2697480"/>
             <a:ext cx="2414016" cy="777240"/>
           </a:xfrm>
           <a:prstGeom prst="rect">
@@ -7129,13 +7039,13 @@
       </p:sp>
       <p:sp>
         <p:nvSpPr>
-          <p:cNvPr id="24" name="Shape 17"/>
+          <p:cNvPr id="24" name="Shape 16"/>
           <p:cNvSpPr/>
           <p:nvPr/>
         </p:nvSpPr>
         <p:spPr>
           <a:xfrm>
-            <a:off x="4389120" y="3520440"/>
+            <a:off x="4389120" y="3657600"/>
             <a:ext cx="3465576" cy="777240"/>
           </a:xfrm>
           <a:prstGeom prst="roundRect">
@@ -7163,13 +7073,13 @@
       </p:sp>
       <p:sp>
         <p:nvSpPr>
-          <p:cNvPr id="25" name="Shape 18"/>
+          <p:cNvPr id="25" name="Shape 17"/>
           <p:cNvSpPr/>
           <p:nvPr/>
         </p:nvSpPr>
         <p:spPr>
           <a:xfrm>
-            <a:off x="4590288" y="3643884"/>
+            <a:off x="4590288" y="3781044"/>
             <a:ext cx="530352" cy="530352"/>
           </a:xfrm>
           <a:prstGeom prst="ellipse">
@@ -7188,21 +7098,21 @@
       </p:sp>
       <p:pic>
         <p:nvPicPr>
-          <p:cNvPr id="26" name="Image 4" descr="preencoded.png">    </p:cNvPr>
+          <p:cNvPr id="26" name="Image 5" descr="preencoded.png">    </p:cNvPr>
           <p:cNvPicPr>
             <a:picLocks noChangeAspect="1"/>
           </p:cNvPicPr>
           <p:nvPr/>
         </p:nvPicPr>
         <p:blipFill>
-          <a:blip r:embed="rId5"/>
+          <a:blip r:embed="rId6"/>
           <a:stretch>
             <a:fillRect/>
           </a:stretch>
         </p:blipFill>
         <p:spPr>
           <a:xfrm>
-            <a:off x="4733483" y="3787079"/>
+            <a:off x="4733483" y="3924239"/>
             <a:ext cx="243962" cy="243962"/>
           </a:xfrm>
           <a:prstGeom prst="rect">
@@ -7212,13 +7122,13 @@
       </p:pic>
       <p:sp>
         <p:nvSpPr>
-          <p:cNvPr id="27" name="Text 19"/>
+          <p:cNvPr id="27" name="Text 18"/>
           <p:cNvSpPr txBox="1"/>
           <p:nvPr/>
         </p:nvSpPr>
         <p:spPr>
           <a:xfrm>
-            <a:off x="5285232" y="3520440"/>
+            <a:off x="5285232" y="3657600"/>
             <a:ext cx="2414016" cy="777240"/>
           </a:xfrm>
           <a:prstGeom prst="rect">
@@ -7251,13 +7161,13 @@
       </p:sp>
       <p:sp>
         <p:nvSpPr>
-          <p:cNvPr id="28" name="Shape 20"/>
+          <p:cNvPr id="28" name="Shape 19"/>
           <p:cNvSpPr/>
           <p:nvPr/>
         </p:nvSpPr>
         <p:spPr>
           <a:xfrm>
-            <a:off x="8083296" y="3520440"/>
+            <a:off x="8083296" y="3657600"/>
             <a:ext cx="3465576" cy="777240"/>
           </a:xfrm>
           <a:prstGeom prst="roundRect">
@@ -7285,13 +7195,13 @@
       </p:sp>
       <p:sp>
         <p:nvSpPr>
-          <p:cNvPr id="29" name="Shape 21"/>
+          <p:cNvPr id="29" name="Shape 20"/>
           <p:cNvSpPr/>
           <p:nvPr/>
         </p:nvSpPr>
         <p:spPr>
           <a:xfrm>
-            <a:off x="8284464" y="3643884"/>
+            <a:off x="8284464" y="3781044"/>
             <a:ext cx="530352" cy="530352"/>
           </a:xfrm>
           <a:prstGeom prst="ellipse">
@@ -7310,21 +7220,21 @@
       </p:sp>
       <p:pic>
         <p:nvPicPr>
-          <p:cNvPr id="30" name="Image 5" descr="preencoded.png">    </p:cNvPr>
+          <p:cNvPr id="30" name="Image 6" descr="preencoded.png">    </p:cNvPr>
           <p:cNvPicPr>
             <a:picLocks noChangeAspect="1"/>
           </p:cNvPicPr>
           <p:nvPr/>
         </p:nvPicPr>
         <p:blipFill>
-          <a:blip r:embed="rId6"/>
+          <a:blip r:embed="rId7"/>
           <a:stretch>
             <a:fillRect/>
           </a:stretch>
         </p:blipFill>
         <p:spPr>
           <a:xfrm>
-            <a:off x="8427659" y="3787079"/>
+            <a:off x="8427659" y="3924239"/>
             <a:ext cx="243962" cy="243962"/>
           </a:xfrm>
           <a:prstGeom prst="rect">
@@ -7334,13 +7244,13 @@
       </p:pic>
       <p:sp>
         <p:nvSpPr>
-          <p:cNvPr id="31" name="Text 22"/>
+          <p:cNvPr id="31" name="Text 21"/>
           <p:cNvSpPr txBox="1"/>
           <p:nvPr/>
         </p:nvSpPr>
         <p:spPr>
           <a:xfrm>
-            <a:off x="8979408" y="3520440"/>
+            <a:off x="8979408" y="3657600"/>
             <a:ext cx="2414016" cy="777240"/>
           </a:xfrm>
           <a:prstGeom prst="rect">
@@ -7373,13 +7283,13 @@
       </p:sp>
       <p:sp>
         <p:nvSpPr>
-          <p:cNvPr id="32" name="Shape 23"/>
+          <p:cNvPr id="32" name="Shape 22"/>
           <p:cNvSpPr/>
           <p:nvPr/>
         </p:nvSpPr>
         <p:spPr>
           <a:xfrm>
-            <a:off x="4389120" y="4526280"/>
+            <a:off x="4389120" y="4663440"/>
             <a:ext cx="7159752" cy="1600200"/>
           </a:xfrm>
           <a:prstGeom prst="roundRect">
@@ -7407,13 +7317,13 @@
       </p:sp>
       <p:sp>
         <p:nvSpPr>
-          <p:cNvPr id="33" name="Shape 24"/>
+          <p:cNvPr id="33" name="Shape 23"/>
           <p:cNvSpPr/>
           <p:nvPr/>
         </p:nvSpPr>
         <p:spPr>
           <a:xfrm>
-            <a:off x="4754880" y="4937760"/>
+            <a:off x="4754880" y="5074920"/>
             <a:ext cx="777240" cy="777240"/>
           </a:xfrm>
           <a:prstGeom prst="ellipse">
@@ -7432,21 +7342,21 @@
       </p:sp>
       <p:pic>
         <p:nvPicPr>
-          <p:cNvPr id="34" name="Image 6" descr="preencoded.png">    </p:cNvPr>
+          <p:cNvPr id="34" name="Image 7" descr="preencoded.png">    </p:cNvPr>
           <p:cNvPicPr>
             <a:picLocks noChangeAspect="1"/>
           </p:cNvPicPr>
           <p:nvPr/>
         </p:nvPicPr>
         <p:blipFill>
-          <a:blip r:embed="rId7"/>
+          <a:blip r:embed="rId8"/>
           <a:stretch>
             <a:fillRect/>
           </a:stretch>
         </p:blipFill>
         <p:spPr>
           <a:xfrm>
-            <a:off x="4964735" y="5147615"/>
+            <a:off x="4964735" y="5284775"/>
             <a:ext cx="357530" cy="357530"/>
           </a:xfrm>
           <a:prstGeom prst="rect">
@@ -7456,13 +7366,13 @@
       </p:pic>
       <p:sp>
         <p:nvSpPr>
-          <p:cNvPr id="35" name="Text 25"/>
+          <p:cNvPr id="35" name="Text 24"/>
           <p:cNvSpPr txBox="1"/>
           <p:nvPr/>
         </p:nvSpPr>
         <p:spPr>
           <a:xfrm>
-            <a:off x="5806440" y="4526280"/>
+            <a:off x="5806440" y="4663440"/>
             <a:ext cx="5422392" cy="1600200"/>
           </a:xfrm>
           <a:prstGeom prst="rect">
@@ -7548,16 +7458,40 @@
           <a:chExt cx="0" cy="0"/>
         </a:xfrm>
       </p:grpSpPr>
-      <p:sp>
-        <p:nvSpPr>
-          <p:cNvPr id="3" name="Text 0"/>
+      <p:pic>
+        <p:nvPicPr>
+          <p:cNvPr id="3" name="Image 0" descr="Breaking Barriers at work">    </p:cNvPr>
+          <p:cNvPicPr>
+            <a:picLocks noChangeAspect="1"/>
+          </p:cNvPicPr>
+          <p:nvPr/>
+        </p:nvPicPr>
+        <p:blipFill>
+          <a:blip r:embed="rId1"/>
+          <a:stretch>
+            <a:fillRect/>
+          </a:stretch>
+        </p:blipFill>
+        <p:spPr>
+          <a:xfrm>
+            <a:off x="640080" y="274320"/>
+            <a:ext cx="1188720" cy="542536"/>
+          </a:xfrm>
+          <a:prstGeom prst="rect">
+            <a:avLst/>
+          </a:prstGeom>
+        </p:spPr>
+      </p:pic>
+      <p:sp>
+        <p:nvSpPr>
+          <p:cNvPr id="4" name="Text 0"/>
           <p:cNvSpPr txBox="1"/>
           <p:nvPr/>
         </p:nvSpPr>
         <p:spPr>
           <a:xfrm>
-            <a:off x="640080" y="384048"/>
-            <a:ext cx="4572000" cy="274320"/>
+            <a:off x="7891272" y="384048"/>
+            <a:ext cx="3657600" cy="274320"/>
           </a:xfrm>
           <a:prstGeom prst="rect">
             <a:avLst/>
@@ -7569,86 +7503,47 @@
           <a:bodyPr wrap="square" lIns="0" tIns="0" rIns="0" bIns="0" rtlCol="0" anchor="ctr"/>
           <a:lstStyle/>
           <a:p>
-            <a:pPr indent="0" marL="0">
-              <a:buNone/>
-            </a:pPr>
-            <a:r>
-              <a:rPr lang="en-US" sz="1050" b="1" spc="300" kern="0" dirty="0">
-                <a:solidFill>
-                  <a:srgbClr val="C68C6C"/>
+            <a:pPr algn="r" indent="0" marL="0">
+              <a:buNone/>
+            </a:pPr>
+            <a:r>
+              <a:rPr lang="en-US" sz="1100" i="1" dirty="0">
+                <a:solidFill>
+                  <a:srgbClr val="8A6A55"/>
+                </a:solidFill>
+                <a:latin typeface="Source Serif Pro" pitchFamily="34" charset="0"/>
+                <a:ea typeface="Source Serif Pro" pitchFamily="34" charset="-122"/>
+                <a:cs typeface="Source Serif Pro" pitchFamily="34" charset="-120"/>
+              </a:rPr>
+              <a:t>by Flor Pérsico</a:t>
+            </a:r>
+            <a:pPr algn="r" indent="0" marL="0">
+              <a:buNone/>
+            </a:pPr>
+            <a:r>
+              <a:rPr lang="en-US" sz="1100" dirty="0">
+                <a:solidFill>
+                  <a:srgbClr val="8A6A55"/>
                 </a:solidFill>
                 <a:latin typeface="Open Sans" pitchFamily="34" charset="0"/>
                 <a:ea typeface="Open Sans" pitchFamily="34" charset="-122"/>
                 <a:cs typeface="Open Sans" pitchFamily="34" charset="-120"/>
               </a:rPr>
-              <a:t>BREAKING BARRIERS · AT WORK</a:t>
-            </a:r>
-            <a:endParaRPr lang="en-US" sz="1050" dirty="0"/>
-          </a:p>
-        </p:txBody>
-      </p:sp>
-      <p:sp>
-        <p:nvSpPr>
-          <p:cNvPr id="4" name="Text 1"/>
+              <a:t>   ·   08 / 09</a:t>
+            </a:r>
+            <a:endParaRPr lang="en-US" sz="1100" dirty="0"/>
+          </a:p>
+        </p:txBody>
+      </p:sp>
+      <p:sp>
+        <p:nvSpPr>
+          <p:cNvPr id="5" name="Text 1"/>
           <p:cNvSpPr txBox="1"/>
           <p:nvPr/>
         </p:nvSpPr>
         <p:spPr>
           <a:xfrm>
-            <a:off x="7891272" y="384048"/>
-            <a:ext cx="3657600" cy="274320"/>
-          </a:xfrm>
-          <a:prstGeom prst="rect">
-            <a:avLst/>
-          </a:prstGeom>
-          <a:noFill/>
-          <a:ln/>
-        </p:spPr>
-        <p:txBody>
-          <a:bodyPr wrap="square" lIns="0" tIns="0" rIns="0" bIns="0" rtlCol="0" anchor="ctr"/>
-          <a:lstStyle/>
-          <a:p>
-            <a:pPr algn="r" indent="0" marL="0">
-              <a:buNone/>
-            </a:pPr>
-            <a:r>
-              <a:rPr lang="en-US" sz="1100" i="1" dirty="0">
-                <a:solidFill>
-                  <a:srgbClr val="8A6A55"/>
-                </a:solidFill>
-                <a:latin typeface="Source Serif Pro" pitchFamily="34" charset="0"/>
-                <a:ea typeface="Source Serif Pro" pitchFamily="34" charset="-122"/>
-                <a:cs typeface="Source Serif Pro" pitchFamily="34" charset="-120"/>
-              </a:rPr>
-              <a:t>by Flor Pérsico</a:t>
-            </a:r>
-            <a:pPr algn="r" indent="0" marL="0">
-              <a:buNone/>
-            </a:pPr>
-            <a:r>
-              <a:rPr lang="en-US" sz="1100" dirty="0">
-                <a:solidFill>
-                  <a:srgbClr val="8A6A55"/>
-                </a:solidFill>
-                <a:latin typeface="Open Sans" pitchFamily="34" charset="0"/>
-                <a:ea typeface="Open Sans" pitchFamily="34" charset="-122"/>
-                <a:cs typeface="Open Sans" pitchFamily="34" charset="-120"/>
-              </a:rPr>
-              <a:t>   ·   08 / 09</a:t>
-            </a:r>
-            <a:endParaRPr lang="en-US" sz="1100" dirty="0"/>
-          </a:p>
-        </p:txBody>
-      </p:sp>
-      <p:sp>
-        <p:nvSpPr>
-          <p:cNvPr id="5" name="Text 2"/>
-          <p:cNvSpPr txBox="1"/>
-          <p:nvPr/>
-        </p:nvSpPr>
-        <p:spPr>
-          <a:xfrm>
-            <a:off x="640080" y="1097280"/>
+            <a:off x="640080" y="1280160"/>
             <a:ext cx="3429000" cy="1783080"/>
           </a:xfrm>
           <a:prstGeom prst="rect">
@@ -7684,13 +7579,13 @@
       </p:sp>
       <p:sp>
         <p:nvSpPr>
-          <p:cNvPr id="6" name="Text 3"/>
+          <p:cNvPr id="6" name="Text 2"/>
           <p:cNvSpPr txBox="1"/>
           <p:nvPr/>
         </p:nvSpPr>
         <p:spPr>
           <a:xfrm>
-            <a:off x="640080" y="1892808"/>
+            <a:off x="640080" y="2075688"/>
             <a:ext cx="3291840" cy="731520"/>
           </a:xfrm>
           <a:prstGeom prst="rect">
@@ -7723,13 +7618,13 @@
       </p:sp>
       <p:sp>
         <p:nvSpPr>
-          <p:cNvPr id="7" name="Shape 4"/>
+          <p:cNvPr id="7" name="Shape 3"/>
           <p:cNvSpPr/>
           <p:nvPr/>
         </p:nvSpPr>
         <p:spPr>
           <a:xfrm>
-            <a:off x="4389120" y="1143000"/>
+            <a:off x="4389120" y="1280160"/>
             <a:ext cx="3442716" cy="3611880"/>
           </a:xfrm>
           <a:prstGeom prst="roundRect">
@@ -7757,13 +7652,13 @@
       </p:sp>
       <p:sp>
         <p:nvSpPr>
-          <p:cNvPr id="8" name="Text 5"/>
+          <p:cNvPr id="8" name="Text 4"/>
           <p:cNvSpPr txBox="1"/>
           <p:nvPr/>
         </p:nvSpPr>
         <p:spPr>
           <a:xfrm>
-            <a:off x="4754880" y="1417320"/>
+            <a:off x="4754880" y="1554480"/>
             <a:ext cx="2711196" cy="502920"/>
           </a:xfrm>
           <a:prstGeom prst="rect">
@@ -7796,13 +7691,13 @@
       </p:sp>
       <p:sp>
         <p:nvSpPr>
-          <p:cNvPr id="9" name="Text 6"/>
+          <p:cNvPr id="9" name="Text 5"/>
           <p:cNvSpPr txBox="1"/>
           <p:nvPr/>
         </p:nvSpPr>
         <p:spPr>
           <a:xfrm>
-            <a:off x="4754880" y="2057400"/>
+            <a:off x="4754880" y="2194560"/>
             <a:ext cx="2802636" cy="2514600"/>
           </a:xfrm>
           <a:prstGeom prst="rect">
@@ -7923,13 +7818,13 @@
       </p:sp>
       <p:sp>
         <p:nvSpPr>
-          <p:cNvPr id="10" name="Shape 7"/>
+          <p:cNvPr id="10" name="Shape 6"/>
           <p:cNvSpPr/>
           <p:nvPr/>
         </p:nvSpPr>
         <p:spPr>
           <a:xfrm>
-            <a:off x="8106156" y="1143000"/>
+            <a:off x="8106156" y="1280160"/>
             <a:ext cx="3442716" cy="3611880"/>
           </a:xfrm>
           <a:prstGeom prst="roundRect">
@@ -7957,13 +7852,13 @@
       </p:sp>
       <p:sp>
         <p:nvSpPr>
-          <p:cNvPr id="11" name="Text 8"/>
+          <p:cNvPr id="11" name="Text 7"/>
           <p:cNvSpPr txBox="1"/>
           <p:nvPr/>
         </p:nvSpPr>
         <p:spPr>
           <a:xfrm>
-            <a:off x="8471916" y="1417320"/>
+            <a:off x="8471916" y="1554480"/>
             <a:ext cx="2711196" cy="502920"/>
           </a:xfrm>
           <a:prstGeom prst="rect">
@@ -7996,13 +7891,13 @@
       </p:sp>
       <p:sp>
         <p:nvSpPr>
-          <p:cNvPr id="12" name="Text 9"/>
+          <p:cNvPr id="12" name="Text 8"/>
           <p:cNvSpPr txBox="1"/>
           <p:nvPr/>
         </p:nvSpPr>
         <p:spPr>
           <a:xfrm>
-            <a:off x="8471916" y="2057400"/>
+            <a:off x="8471916" y="2194560"/>
             <a:ext cx="2802636" cy="2514600"/>
           </a:xfrm>
           <a:prstGeom prst="rect">
@@ -8081,13 +7976,13 @@
       </p:sp>
       <p:sp>
         <p:nvSpPr>
-          <p:cNvPr id="13" name="Shape 10"/>
+          <p:cNvPr id="13" name="Shape 9"/>
           <p:cNvSpPr/>
           <p:nvPr/>
         </p:nvSpPr>
         <p:spPr>
           <a:xfrm>
-            <a:off x="4389120" y="5029200"/>
+            <a:off x="4389120" y="5166360"/>
             <a:ext cx="7159752" cy="1051560"/>
           </a:xfrm>
           <a:prstGeom prst="roundRect">
@@ -8115,13 +8010,13 @@
       </p:sp>
       <p:sp>
         <p:nvSpPr>
-          <p:cNvPr id="14" name="Shape 11"/>
+          <p:cNvPr id="14" name="Shape 10"/>
           <p:cNvSpPr/>
           <p:nvPr/>
         </p:nvSpPr>
         <p:spPr>
           <a:xfrm>
-            <a:off x="4754880" y="5230368"/>
+            <a:off x="4754880" y="5367528"/>
             <a:ext cx="640080" cy="640080"/>
           </a:xfrm>
           <a:prstGeom prst="ellipse">
@@ -8140,21 +8035,21 @@
       </p:sp>
       <p:pic>
         <p:nvPicPr>
-          <p:cNvPr id="15" name="Image 0" descr="preencoded.png">    </p:cNvPr>
+          <p:cNvPr id="15" name="Image 1" descr="preencoded.png">    </p:cNvPr>
           <p:cNvPicPr>
             <a:picLocks noChangeAspect="1"/>
           </p:cNvPicPr>
           <p:nvPr/>
         </p:nvPicPr>
         <p:blipFill>
-          <a:blip r:embed="rId1"/>
+          <a:blip r:embed="rId2"/>
           <a:stretch>
             <a:fillRect/>
           </a:stretch>
         </p:blipFill>
         <p:spPr>
           <a:xfrm>
-            <a:off x="4927702" y="5403190"/>
+            <a:off x="4927702" y="5540350"/>
             <a:ext cx="294437" cy="294437"/>
           </a:xfrm>
           <a:prstGeom prst="rect">
@@ -8164,13 +8059,13 @@
       </p:pic>
       <p:sp>
         <p:nvSpPr>
-          <p:cNvPr id="16" name="Text 12"/>
+          <p:cNvPr id="16" name="Text 11"/>
           <p:cNvSpPr txBox="1"/>
           <p:nvPr/>
         </p:nvSpPr>
         <p:spPr>
           <a:xfrm>
-            <a:off x="5623560" y="5029200"/>
+            <a:off x="5623560" y="5166360"/>
             <a:ext cx="5605272" cy="1051560"/>
           </a:xfrm>
           <a:prstGeom prst="rect">
@@ -8247,16 +8142,40 @@
           <a:chExt cx="0" cy="0"/>
         </a:xfrm>
       </p:grpSpPr>
-      <p:sp>
-        <p:nvSpPr>
-          <p:cNvPr id="3" name="Text 0"/>
+      <p:pic>
+        <p:nvPicPr>
+          <p:cNvPr id="3" name="Image 0" descr="Breaking Barriers at work">    </p:cNvPr>
+          <p:cNvPicPr>
+            <a:picLocks noChangeAspect="1"/>
+          </p:cNvPicPr>
+          <p:nvPr/>
+        </p:nvPicPr>
+        <p:blipFill>
+          <a:blip r:embed="rId1"/>
+          <a:stretch>
+            <a:fillRect/>
+          </a:stretch>
+        </p:blipFill>
+        <p:spPr>
+          <a:xfrm>
+            <a:off x="640080" y="274320"/>
+            <a:ext cx="1188720" cy="542536"/>
+          </a:xfrm>
+          <a:prstGeom prst="rect">
+            <a:avLst/>
+          </a:prstGeom>
+        </p:spPr>
+      </p:pic>
+      <p:sp>
+        <p:nvSpPr>
+          <p:cNvPr id="4" name="Text 0"/>
           <p:cNvSpPr txBox="1"/>
           <p:nvPr/>
         </p:nvSpPr>
         <p:spPr>
           <a:xfrm>
-            <a:off x="640080" y="384048"/>
-            <a:ext cx="4572000" cy="274320"/>
+            <a:off x="7891272" y="384048"/>
+            <a:ext cx="3657600" cy="274320"/>
           </a:xfrm>
           <a:prstGeom prst="rect">
             <a:avLst/>
@@ -8268,11 +8187,25 @@
           <a:bodyPr wrap="square" lIns="0" tIns="0" rIns="0" bIns="0" rtlCol="0" anchor="ctr"/>
           <a:lstStyle/>
           <a:p>
-            <a:pPr indent="0" marL="0">
-              <a:buNone/>
-            </a:pPr>
-            <a:r>
-              <a:rPr lang="en-US" sz="1050" b="1" spc="300" kern="0" dirty="0">
+            <a:pPr algn="r" indent="0" marL="0">
+              <a:buNone/>
+            </a:pPr>
+            <a:r>
+              <a:rPr lang="en-US" sz="1100" i="1" dirty="0">
+                <a:solidFill>
+                  <a:srgbClr val="3F1E0D"/>
+                </a:solidFill>
+                <a:latin typeface="Source Serif Pro" pitchFamily="34" charset="0"/>
+                <a:ea typeface="Source Serif Pro" pitchFamily="34" charset="-122"/>
+                <a:cs typeface="Source Serif Pro" pitchFamily="34" charset="-120"/>
+              </a:rPr>
+              <a:t>by Flor Pérsico</a:t>
+            </a:r>
+            <a:pPr algn="r" indent="0" marL="0">
+              <a:buNone/>
+            </a:pPr>
+            <a:r>
+              <a:rPr lang="en-US" sz="1100" dirty="0">
                 <a:solidFill>
                   <a:srgbClr val="3F1E0D"/>
                 </a:solidFill>
@@ -8280,74 +8213,21 @@
                 <a:ea typeface="Open Sans" pitchFamily="34" charset="-122"/>
                 <a:cs typeface="Open Sans" pitchFamily="34" charset="-120"/>
               </a:rPr>
-              <a:t>BREAKING BARRIERS · AT WORK</a:t>
-            </a:r>
-            <a:endParaRPr lang="en-US" sz="1050" dirty="0"/>
-          </a:p>
-        </p:txBody>
-      </p:sp>
-      <p:sp>
-        <p:nvSpPr>
-          <p:cNvPr id="4" name="Text 1"/>
+              <a:t>   ·   09 / 09</a:t>
+            </a:r>
+            <a:endParaRPr lang="en-US" sz="1100" dirty="0"/>
+          </a:p>
+        </p:txBody>
+      </p:sp>
+      <p:sp>
+        <p:nvSpPr>
+          <p:cNvPr id="5" name="Text 1"/>
           <p:cNvSpPr txBox="1"/>
           <p:nvPr/>
         </p:nvSpPr>
         <p:spPr>
           <a:xfrm>
-            <a:off x="7891272" y="384048"/>
-            <a:ext cx="3657600" cy="274320"/>
-          </a:xfrm>
-          <a:prstGeom prst="rect">
-            <a:avLst/>
-          </a:prstGeom>
-          <a:noFill/>
-          <a:ln/>
-        </p:spPr>
-        <p:txBody>
-          <a:bodyPr wrap="square" lIns="0" tIns="0" rIns="0" bIns="0" rtlCol="0" anchor="ctr"/>
-          <a:lstStyle/>
-          <a:p>
-            <a:pPr algn="r" indent="0" marL="0">
-              <a:buNone/>
-            </a:pPr>
-            <a:r>
-              <a:rPr lang="en-US" sz="1100" i="1" dirty="0">
-                <a:solidFill>
-                  <a:srgbClr val="3F1E0D"/>
-                </a:solidFill>
-                <a:latin typeface="Source Serif Pro" pitchFamily="34" charset="0"/>
-                <a:ea typeface="Source Serif Pro" pitchFamily="34" charset="-122"/>
-                <a:cs typeface="Source Serif Pro" pitchFamily="34" charset="-120"/>
-              </a:rPr>
-              <a:t>by Flor Pérsico</a:t>
-            </a:r>
-            <a:pPr algn="r" indent="0" marL="0">
-              <a:buNone/>
-            </a:pPr>
-            <a:r>
-              <a:rPr lang="en-US" sz="1100" dirty="0">
-                <a:solidFill>
-                  <a:srgbClr val="3F1E0D"/>
-                </a:solidFill>
-                <a:latin typeface="Open Sans" pitchFamily="34" charset="0"/>
-                <a:ea typeface="Open Sans" pitchFamily="34" charset="-122"/>
-                <a:cs typeface="Open Sans" pitchFamily="34" charset="-120"/>
-              </a:rPr>
-              <a:t>   ·   09 / 09</a:t>
-            </a:r>
-            <a:endParaRPr lang="en-US" sz="1100" dirty="0"/>
-          </a:p>
-        </p:txBody>
-      </p:sp>
-      <p:sp>
-        <p:nvSpPr>
-          <p:cNvPr id="5" name="Text 2"/>
-          <p:cNvSpPr txBox="1"/>
-          <p:nvPr/>
-        </p:nvSpPr>
-        <p:spPr>
-          <a:xfrm>
-            <a:off x="640080" y="1097280"/>
+            <a:off x="640080" y="1280160"/>
             <a:ext cx="3429000" cy="1783080"/>
           </a:xfrm>
           <a:prstGeom prst="rect">
@@ -8383,13 +8263,13 @@
       </p:sp>
       <p:sp>
         <p:nvSpPr>
-          <p:cNvPr id="6" name="Text 3"/>
+          <p:cNvPr id="6" name="Text 2"/>
           <p:cNvSpPr txBox="1"/>
           <p:nvPr/>
         </p:nvSpPr>
         <p:spPr>
           <a:xfrm>
-            <a:off x="640080" y="2414016"/>
+            <a:off x="640080" y="2596896"/>
             <a:ext cx="3291840" cy="731520"/>
           </a:xfrm>
           <a:prstGeom prst="rect">
@@ -8422,13 +8302,13 @@
       </p:sp>
       <p:sp>
         <p:nvSpPr>
-          <p:cNvPr id="7" name="Shape 4"/>
+          <p:cNvPr id="7" name="Shape 3"/>
           <p:cNvSpPr/>
           <p:nvPr/>
         </p:nvSpPr>
         <p:spPr>
           <a:xfrm>
-            <a:off x="4389120" y="1143000"/>
+            <a:off x="4389120" y="1280160"/>
             <a:ext cx="7159752" cy="1051560"/>
           </a:xfrm>
           <a:prstGeom prst="roundRect">
@@ -8456,13 +8336,13 @@
       </p:sp>
       <p:sp>
         <p:nvSpPr>
-          <p:cNvPr id="8" name="Shape 5"/>
+          <p:cNvPr id="8" name="Shape 4"/>
           <p:cNvSpPr/>
           <p:nvPr/>
         </p:nvSpPr>
         <p:spPr>
           <a:xfrm>
-            <a:off x="4709160" y="1348740"/>
+            <a:off x="4709160" y="1485900"/>
             <a:ext cx="640080" cy="640080"/>
           </a:xfrm>
           <a:prstGeom prst="ellipse">
@@ -8481,21 +8361,21 @@
       </p:sp>
       <p:pic>
         <p:nvPicPr>
-          <p:cNvPr id="9" name="Image 0" descr="preencoded.png">    </p:cNvPr>
+          <p:cNvPr id="9" name="Image 1" descr="preencoded.png">    </p:cNvPr>
           <p:cNvPicPr>
             <a:picLocks noChangeAspect="1"/>
           </p:cNvPicPr>
           <p:nvPr/>
         </p:nvPicPr>
         <p:blipFill>
-          <a:blip r:embed="rId1"/>
+          <a:blip r:embed="rId2"/>
           <a:stretch>
             <a:fillRect/>
           </a:stretch>
         </p:blipFill>
         <p:spPr>
           <a:xfrm>
-            <a:off x="4881982" y="1521562"/>
+            <a:off x="4881982" y="1658722"/>
             <a:ext cx="294437" cy="294437"/>
           </a:xfrm>
           <a:prstGeom prst="rect">
@@ -8505,13 +8385,13 @@
       </p:pic>
       <p:sp>
         <p:nvSpPr>
-          <p:cNvPr id="10" name="Text 6"/>
+          <p:cNvPr id="10" name="Text 5"/>
           <p:cNvSpPr txBox="1"/>
           <p:nvPr/>
         </p:nvSpPr>
         <p:spPr>
           <a:xfrm>
-            <a:off x="5623560" y="1143000"/>
+            <a:off x="5623560" y="1280160"/>
             <a:ext cx="5605272" cy="1051560"/>
           </a:xfrm>
           <a:prstGeom prst="rect">
@@ -8572,13 +8452,13 @@
       </p:sp>
       <p:sp>
         <p:nvSpPr>
-          <p:cNvPr id="11" name="Shape 7"/>
+          <p:cNvPr id="11" name="Shape 6"/>
           <p:cNvSpPr/>
           <p:nvPr/>
         </p:nvSpPr>
         <p:spPr>
           <a:xfrm>
-            <a:off x="4389120" y="2395728"/>
+            <a:off x="4389120" y="2532888"/>
             <a:ext cx="7159752" cy="1051560"/>
           </a:xfrm>
           <a:prstGeom prst="roundRect">
@@ -8606,13 +8486,13 @@
       </p:sp>
       <p:sp>
         <p:nvSpPr>
-          <p:cNvPr id="12" name="Shape 8"/>
+          <p:cNvPr id="12" name="Shape 7"/>
           <p:cNvSpPr/>
           <p:nvPr/>
         </p:nvSpPr>
         <p:spPr>
           <a:xfrm>
-            <a:off x="4709160" y="2601468"/>
+            <a:off x="4709160" y="2738628"/>
             <a:ext cx="640080" cy="640080"/>
           </a:xfrm>
           <a:prstGeom prst="ellipse">
@@ -8631,21 +8511,21 @@
       </p:sp>
       <p:pic>
         <p:nvPicPr>
-          <p:cNvPr id="13" name="Image 1" descr="preencoded.png">    </p:cNvPr>
+          <p:cNvPr id="13" name="Image 2" descr="preencoded.png">    </p:cNvPr>
           <p:cNvPicPr>
             <a:picLocks noChangeAspect="1"/>
           </p:cNvPicPr>
           <p:nvPr/>
         </p:nvPicPr>
         <p:blipFill>
-          <a:blip r:embed="rId2"/>
+          <a:blip r:embed="rId3"/>
           <a:stretch>
             <a:fillRect/>
           </a:stretch>
         </p:blipFill>
         <p:spPr>
           <a:xfrm>
-            <a:off x="4881982" y="2774290"/>
+            <a:off x="4881982" y="2911450"/>
             <a:ext cx="294437" cy="294437"/>
           </a:xfrm>
           <a:prstGeom prst="rect">
@@ -8655,13 +8535,13 @@
       </p:pic>
       <p:sp>
         <p:nvSpPr>
-          <p:cNvPr id="14" name="Text 9"/>
+          <p:cNvPr id="14" name="Text 8"/>
           <p:cNvSpPr txBox="1"/>
           <p:nvPr/>
         </p:nvSpPr>
         <p:spPr>
           <a:xfrm>
-            <a:off x="5623560" y="2395728"/>
+            <a:off x="5623560" y="2532888"/>
             <a:ext cx="5605272" cy="1051560"/>
           </a:xfrm>
           <a:prstGeom prst="rect">
@@ -8694,13 +8574,13 @@
       </p:sp>
       <p:sp>
         <p:nvSpPr>
-          <p:cNvPr id="15" name="Shape 10"/>
+          <p:cNvPr id="15" name="Shape 9"/>
           <p:cNvSpPr/>
           <p:nvPr/>
         </p:nvSpPr>
         <p:spPr>
           <a:xfrm>
-            <a:off x="4389120" y="3648456"/>
+            <a:off x="4389120" y="3785616"/>
             <a:ext cx="7159752" cy="1051560"/>
           </a:xfrm>
           <a:prstGeom prst="roundRect">
@@ -8728,13 +8608,13 @@
       </p:sp>
       <p:sp>
         <p:nvSpPr>
-          <p:cNvPr id="16" name="Shape 11"/>
+          <p:cNvPr id="16" name="Shape 10"/>
           <p:cNvSpPr/>
           <p:nvPr/>
         </p:nvSpPr>
         <p:spPr>
           <a:xfrm>
-            <a:off x="4709160" y="3854196"/>
+            <a:off x="4709160" y="3991356"/>
             <a:ext cx="640080" cy="640080"/>
           </a:xfrm>
           <a:prstGeom prst="ellipse">
@@ -8753,21 +8633,21 @@
       </p:sp>
       <p:pic>
         <p:nvPicPr>
-          <p:cNvPr id="17" name="Image 2" descr="preencoded.png">    </p:cNvPr>
+          <p:cNvPr id="17" name="Image 3" descr="preencoded.png">    </p:cNvPr>
           <p:cNvPicPr>
             <a:picLocks noChangeAspect="1"/>
           </p:cNvPicPr>
           <p:nvPr/>
         </p:nvPicPr>
         <p:blipFill>
-          <a:blip r:embed="rId3"/>
+          <a:blip r:embed="rId4"/>
           <a:stretch>
             <a:fillRect/>
           </a:stretch>
         </p:blipFill>
         <p:spPr>
           <a:xfrm>
-            <a:off x="4881982" y="4027018"/>
+            <a:off x="4881982" y="4164178"/>
             <a:ext cx="294437" cy="294437"/>
           </a:xfrm>
           <a:prstGeom prst="rect">
@@ -8777,13 +8657,13 @@
       </p:pic>
       <p:sp>
         <p:nvSpPr>
-          <p:cNvPr id="18" name="Text 12"/>
+          <p:cNvPr id="18" name="Text 11"/>
           <p:cNvSpPr txBox="1"/>
           <p:nvPr/>
         </p:nvSpPr>
         <p:spPr>
           <a:xfrm>
-            <a:off x="5623560" y="3648456"/>
+            <a:off x="5623560" y="3785616"/>
             <a:ext cx="5605272" cy="1051560"/>
           </a:xfrm>
           <a:prstGeom prst="rect">
@@ -8830,13 +8710,13 @@
       </p:sp>
       <p:sp>
         <p:nvSpPr>
-          <p:cNvPr id="19" name="Shape 13"/>
+          <p:cNvPr id="19" name="Shape 12"/>
           <p:cNvSpPr/>
           <p:nvPr/>
         </p:nvSpPr>
         <p:spPr>
           <a:xfrm>
-            <a:off x="4389120" y="4901184"/>
+            <a:off x="4389120" y="5038344"/>
             <a:ext cx="7159752" cy="1051560"/>
           </a:xfrm>
           <a:prstGeom prst="roundRect">
@@ -8864,13 +8744,13 @@
       </p:sp>
       <p:sp>
         <p:nvSpPr>
-          <p:cNvPr id="20" name="Shape 14"/>
+          <p:cNvPr id="20" name="Shape 13"/>
           <p:cNvSpPr/>
           <p:nvPr/>
         </p:nvSpPr>
         <p:spPr>
           <a:xfrm>
-            <a:off x="4709160" y="5106924"/>
+            <a:off x="4709160" y="5244084"/>
             <a:ext cx="640080" cy="640080"/>
           </a:xfrm>
           <a:prstGeom prst="ellipse">
@@ -8889,21 +8769,21 @@
       </p:sp>
       <p:pic>
         <p:nvPicPr>
-          <p:cNvPr id="21" name="Image 3" descr="preencoded.png">    </p:cNvPr>
+          <p:cNvPr id="21" name="Image 4" descr="preencoded.png">    </p:cNvPr>
           <p:cNvPicPr>
             <a:picLocks noChangeAspect="1"/>
           </p:cNvPicPr>
           <p:nvPr/>
         </p:nvPicPr>
         <p:blipFill>
-          <a:blip r:embed="rId4"/>
+          <a:blip r:embed="rId5"/>
           <a:stretch>
             <a:fillRect/>
           </a:stretch>
         </p:blipFill>
         <p:spPr>
           <a:xfrm>
-            <a:off x="4881982" y="5279746"/>
+            <a:off x="4881982" y="5416906"/>
             <a:ext cx="294437" cy="294437"/>
           </a:xfrm>
           <a:prstGeom prst="rect">
@@ -8913,13 +8793,13 @@
       </p:pic>
       <p:sp>
         <p:nvSpPr>
-          <p:cNvPr id="22" name="Text 15"/>
+          <p:cNvPr id="22" name="Text 14"/>
           <p:cNvSpPr txBox="1"/>
           <p:nvPr/>
         </p:nvSpPr>
         <p:spPr>
           <a:xfrm>
-            <a:off x="5623560" y="4901184"/>
+            <a:off x="5623560" y="5038344"/>
             <a:ext cx="5605272" cy="1051560"/>
           </a:xfrm>
           <a:prstGeom prst="rect">

</xml_diff>

<commit_message>
Onboarding coherence fixes before recording
- ONB 07: definitive map (4 stages + weeks + result per stage, week 20 review)
- AT WORK Community name unified (ONB 02, 03, 12)
- ONB 13: email check back in, initial focus tied to Starting Point
- Neutral-Spanish prompters generated from deck notes

Co-Authored-By: Claude Opus 5.5 <noreply@anthropic.com>
Claude-Session: https://claude.ai/code/session_01PSmnUj1LvutfXzpzQBGsxa
</commit_message>
<xml_diff>
--- a/onboarding/ONB02_Como_vamos_a_trabajar_juntas.pptx
+++ b/onboarding/ONB02_Como_vamos_a_trabajar_juntas.pptx
@@ -783,7 +783,7 @@
             <a:r>
               <a:rPr lang="en-US" dirty="0"/>
               <a:t>También quiero que sepas que durante AT WORK no estás sola entre una sesión y la siguiente.
-Si te surge una duda, quieres compartir algo, necesitas feedback o simplemente quieres contarme una situación que pasó en tu trabajo, puedes hacerlo dentro de la comunidad de WhatsApp.
+Si te surge una duda, quieres compartir algo, necesitas feedback o simplemente quieres contarme una situación que pasó en tu trabajo, puedes hacerlo dentro de AT WORK Community, nuestra comunidad de WhatsApp.
 La comunidad va a ser nuestro espacio principal de comunicación durante el programa. Ahí puedes compartir prácticas, hacer preguntas, pedirme feedback, contar un avance o algo que aprendiste durante la semana.
 Si se trata de un tema administrativo o de algo que prefieres mantener en privado, ahí sí puedes escribirme directamente.
 Y cuando una situación necesita más contexto, análisis o trabajo en profundidad, la llevamos a nuestra sesión 1:1 para poder trabajarla bien.
@@ -4297,7 +4297,7 @@
                 <a:ea typeface="Source Serif Pro" pitchFamily="34" charset="-122"/>
                 <a:cs typeface="Source Serif Pro" pitchFamily="34" charset="-120"/>
               </a:rPr>
-              <a:t>Comunidad de WhatsApp</a:t>
+              <a:t>AT WORK Community</a:t>
             </a:r>
             <a:endParaRPr lang="en-US" sz="1700" dirty="0"/>
           </a:p>
@@ -4336,7 +4336,7 @@
                 <a:ea typeface="Open Sans" pitchFamily="34" charset="-122"/>
                 <a:cs typeface="Open Sans" pitchFamily="34" charset="-120"/>
               </a:rPr>
-              <a:t>nuestro espacio principal</a:t>
+              <a:t>en WhatsApp · nuestro espacio principal</a:t>
             </a:r>
             <a:endParaRPr lang="en-US" sz="1050" dirty="0"/>
           </a:p>

</xml_diff>